<commit_message>
Add observability dashboard to presentation
Co-authored-by: yanivbtm-git <yanivbtm-git@users.noreply.github.com>
</commit_message>
<xml_diff>
--- a/presentations/payments_dashboards_summary.pptx
+++ b/presentations/payments_dashboards_summary.pptx
@@ -10,6 +10,7 @@
     <p:sldId id="258" r:id="rId9"/>
     <p:sldId id="259" r:id="rId10"/>
     <p:sldId id="260" r:id="rId11"/>
+    <p:sldId id="267" r:id="rId18"/>
     <p:sldId id="261" r:id="rId12"/>
     <p:sldId id="262" r:id="rId13"/>
     <p:sldId id="263" r:id="rId14"/>
@@ -5708,6 +5709,1670 @@
                 <a:hlinkClick r:id="rId6"/>
               </a:rPr>
               <a:t>Open dashboard</a:t>
+            </a:r>
+          </a:p>
+        </p:txBody>
+      </p:sp>
+      <p:sp>
+        <p:nvSpPr>
+          <p:cNvPr id="32" name="Rounded Rectangle 31"/>
+          <p:cNvSpPr/>
+          <p:nvPr/>
+        </p:nvSpPr>
+        <p:spPr>
+          <a:xfrm>
+            <a:off x="777240" y="5577840"/>
+            <a:ext cx="10607040" cy="685800"/>
+          </a:xfrm>
+          <a:prstGeom prst="roundRect">
+            <a:avLst/>
+          </a:prstGeom>
+          <a:solidFill>
+            <a:srgbClr val="FFFFFF"/>
+          </a:solidFill>
+          <a:ln>
+            <a:solidFill>
+              <a:srgbClr val="D2DDEB"/>
+            </a:solidFill>
+          </a:ln>
+        </p:spPr>
+        <p:style>
+          <a:lnRef idx="1">
+            <a:schemeClr val="accent1"/>
+          </a:lnRef>
+          <a:fillRef idx="3">
+            <a:schemeClr val="accent1"/>
+          </a:fillRef>
+          <a:effectRef idx="2">
+            <a:schemeClr val="accent1"/>
+          </a:effectRef>
+          <a:fontRef idx="minor">
+            <a:schemeClr val="lt1"/>
+          </a:fontRef>
+        </p:style>
+        <p:txBody>
+          <a:bodyPr rtlCol="0" anchor="ctr"/>
+          <a:lstStyle/>
+          <a:p>
+            <a:pPr algn="ctr"/>
+          </a:p>
+        </p:txBody>
+      </p:sp>
+      <p:sp>
+        <p:nvSpPr>
+          <p:cNvPr id="33" name="Rectangle 32"/>
+          <p:cNvSpPr/>
+          <p:nvPr/>
+        </p:nvSpPr>
+        <p:spPr>
+          <a:xfrm>
+            <a:off x="777240" y="5577840"/>
+            <a:ext cx="73152" cy="685800"/>
+          </a:xfrm>
+          <a:prstGeom prst="rect">
+            <a:avLst/>
+          </a:prstGeom>
+          <a:solidFill>
+            <a:srgbClr val="00959C"/>
+          </a:solidFill>
+          <a:ln>
+            <a:noFill/>
+          </a:ln>
+        </p:spPr>
+        <p:style>
+          <a:lnRef idx="1">
+            <a:schemeClr val="accent1"/>
+          </a:lnRef>
+          <a:fillRef idx="3">
+            <a:schemeClr val="accent1"/>
+          </a:fillRef>
+          <a:effectRef idx="2">
+            <a:schemeClr val="accent1"/>
+          </a:effectRef>
+          <a:fontRef idx="minor">
+            <a:schemeClr val="lt1"/>
+          </a:fontRef>
+        </p:style>
+        <p:txBody>
+          <a:bodyPr rtlCol="0" anchor="ctr"/>
+          <a:lstStyle/>
+          <a:p>
+            <a:pPr algn="ctr"/>
+          </a:p>
+        </p:txBody>
+      </p:sp>
+      <p:sp>
+        <p:nvSpPr>
+          <p:cNvPr id="34" name="TextBox 33"/>
+          <p:cNvSpPr txBox="1"/>
+          <p:nvPr/>
+        </p:nvSpPr>
+        <p:spPr>
+          <a:xfrm>
+            <a:off x="978408" y="5715000"/>
+            <a:ext cx="10287000" cy="274320"/>
+          </a:xfrm>
+          <a:prstGeom prst="rect">
+            <a:avLst/>
+          </a:prstGeom>
+          <a:noFill/>
+        </p:spPr>
+        <p:txBody>
+          <a:bodyPr wrap="none">
+            <a:spAutoFit/>
+          </a:bodyPr>
+          <a:lstStyle/>
+          <a:p>
+            <a:pPr>
+              <a:defRPr sz="1000" b="1">
+                <a:solidFill>
+                  <a:srgbClr val="667487"/>
+                </a:solidFill>
+              </a:defRPr>
+            </a:pPr>
+            <a:r>
+              <a:t>Payments Observability Dashboard</a:t>
+            </a:r>
+          </a:p>
+        </p:txBody>
+      </p:sp>
+      <p:sp>
+        <p:nvSpPr>
+          <p:cNvPr id="35" name="TextBox 34"/>
+          <p:cNvSpPr txBox="1"/>
+          <p:nvPr/>
+        </p:nvSpPr>
+        <p:spPr>
+          <a:xfrm>
+            <a:off x="978408" y="6035040"/>
+            <a:ext cx="10287000" cy="0"/>
+          </a:xfrm>
+          <a:prstGeom prst="rect">
+            <a:avLst/>
+          </a:prstGeom>
+          <a:noFill/>
+        </p:spPr>
+        <p:txBody>
+          <a:bodyPr wrap="square">
+            <a:normAutofit/>
+          </a:bodyPr>
+          <a:lstStyle/>
+          <a:p>
+            <a:pPr>
+              <a:spcAft>
+                <a:spcPts val="300"/>
+              </a:spcAft>
+              <a:defRPr sz="950">
+                <a:solidFill>
+                  <a:srgbClr val="222D3D"/>
+                </a:solidFill>
+              </a:defRPr>
+            </a:pPr>
+            <a:r>
+              <a:t>https://payments-c225aa.kb.us-central1.gcp.elastic.cloud:443/app/dashboards#/view/250b10ed-6fa9-4032-bec9-8d7d1a3632f6</a:t>
+            </a:r>
+          </a:p>
+        </p:txBody>
+      </p:sp>
+      <p:sp>
+        <p:nvSpPr>
+          <p:cNvPr id="36" name="TextBox 35"/>
+          <p:cNvSpPr txBox="1"/>
+          <p:nvPr/>
+        </p:nvSpPr>
+        <p:spPr>
+          <a:xfrm>
+            <a:off x="1005840" y="5897880"/>
+            <a:ext cx="7315200" cy="256032"/>
+          </a:xfrm>
+          <a:prstGeom prst="rect">
+            <a:avLst/>
+          </a:prstGeom>
+          <a:noFill/>
+        </p:spPr>
+        <p:txBody>
+          <a:bodyPr wrap="none">
+            <a:spAutoFit/>
+          </a:bodyPr>
+          <a:lstStyle/>
+          <a:p>
+            <a:r>
+              <a:rPr sz="1000" u="sng">
+                <a:solidFill>
+                  <a:srgbClr val="3673C8"/>
+                </a:solidFill>
+                <a:hlinkClick r:id="rId7"/>
+              </a:rPr>
+              <a:t>Open dashboard</a:t>
+            </a:r>
+          </a:p>
+        </p:txBody>
+      </p:sp>
+    </p:spTree>
+  </p:cSld>
+  <p:clrMapOvr>
+    <a:masterClrMapping/>
+  </p:clrMapOvr>
+</p:sld>
+</file>
+
+<file path=ppt/slides/slide12.xml><?xml version="1.0" encoding="utf-8"?>
+<p:sld xmlns:a="http://schemas.openxmlformats.org/drawingml/2006/main" xmlns:p="http://schemas.openxmlformats.org/presentationml/2006/main" xmlns:r="http://schemas.openxmlformats.org/officeDocument/2006/relationships">
+  <p:cSld>
+    <p:bg>
+      <p:bgPr>
+        <a:solidFill>
+          <a:srgbClr val="F4F8FC"/>
+        </a:solidFill>
+        <a:effectLst/>
+      </p:bgPr>
+    </p:bg>
+    <p:spTree>
+      <p:nvGrpSpPr>
+        <p:cNvPr id="1" name=""/>
+        <p:cNvGrpSpPr/>
+        <p:nvPr/>
+      </p:nvGrpSpPr>
+      <p:grpSpPr/>
+      <p:sp>
+        <p:nvSpPr>
+          <p:cNvPr id="2" name="Rectangle 1"/>
+          <p:cNvSpPr/>
+          <p:nvPr/>
+        </p:nvSpPr>
+        <p:spPr>
+          <a:xfrm>
+            <a:off x="0" y="0"/>
+            <a:ext cx="12191695" cy="164592"/>
+          </a:xfrm>
+          <a:prstGeom prst="rect">
+            <a:avLst/>
+          </a:prstGeom>
+          <a:solidFill>
+            <a:srgbClr val="3673C8"/>
+          </a:solidFill>
+          <a:ln>
+            <a:noFill/>
+          </a:ln>
+        </p:spPr>
+        <p:style>
+          <a:lnRef idx="1">
+            <a:schemeClr val="accent1"/>
+          </a:lnRef>
+          <a:fillRef idx="3">
+            <a:schemeClr val="accent1"/>
+          </a:fillRef>
+          <a:effectRef idx="2">
+            <a:schemeClr val="accent1"/>
+          </a:effectRef>
+          <a:fontRef idx="minor">
+            <a:schemeClr val="lt1"/>
+          </a:fontRef>
+        </p:style>
+        <p:txBody>
+          <a:bodyPr rtlCol="0" anchor="ctr"/>
+          <a:lstStyle/>
+          <a:p>
+            <a:pPr algn="ctr"/>
+          </a:p>
+        </p:txBody>
+      </p:sp>
+      <p:sp>
+        <p:nvSpPr>
+          <p:cNvPr id="3" name="TextBox 2"/>
+          <p:cNvSpPr txBox="1"/>
+          <p:nvPr/>
+        </p:nvSpPr>
+        <p:spPr>
+          <a:xfrm>
+            <a:off x="502920" y="320040"/>
+            <a:ext cx="8503920" cy="502920"/>
+          </a:xfrm>
+          <a:prstGeom prst="rect">
+            <a:avLst/>
+          </a:prstGeom>
+          <a:noFill/>
+        </p:spPr>
+        <p:txBody>
+          <a:bodyPr wrap="none">
+            <a:spAutoFit/>
+          </a:bodyPr>
+          <a:lstStyle/>
+          <a:p>
+            <a:pPr>
+              <a:defRPr sz="2400" b="1">
+                <a:solidFill>
+                  <a:srgbClr val="142440"/>
+                </a:solidFill>
+              </a:defRPr>
+            </a:pPr>
+            <a:r>
+              <a:t>Observability Dashboard</a:t>
+            </a:r>
+          </a:p>
+        </p:txBody>
+      </p:sp>
+      <p:sp>
+        <p:nvSpPr>
+          <p:cNvPr id="4" name="TextBox 3"/>
+          <p:cNvSpPr txBox="1"/>
+          <p:nvPr/>
+        </p:nvSpPr>
+        <p:spPr>
+          <a:xfrm>
+            <a:off x="530352" y="822960"/>
+            <a:ext cx="9875520" cy="320040"/>
+          </a:xfrm>
+          <a:prstGeom prst="rect">
+            <a:avLst/>
+          </a:prstGeom>
+          <a:noFill/>
+        </p:spPr>
+        <p:txBody>
+          <a:bodyPr wrap="none">
+            <a:spAutoFit/>
+          </a:bodyPr>
+          <a:lstStyle/>
+          <a:p>
+            <a:pPr>
+              <a:defRPr sz="1050">
+                <a:solidFill>
+                  <a:srgbClr val="667487"/>
+                </a:solidFill>
+              </a:defRPr>
+            </a:pPr>
+            <a:r>
+              <a:t>Service-health view built from the current payment transaction data</a:t>
+            </a:r>
+          </a:p>
+        </p:txBody>
+      </p:sp>
+      <p:sp>
+        <p:nvSpPr>
+          <p:cNvPr id="5" name="TextBox 4"/>
+          <p:cNvSpPr txBox="1"/>
+          <p:nvPr/>
+        </p:nvSpPr>
+        <p:spPr>
+          <a:xfrm>
+            <a:off x="502920" y="6446520"/>
+            <a:ext cx="4572000" cy="228600"/>
+          </a:xfrm>
+          <a:prstGeom prst="rect">
+            <a:avLst/>
+          </a:prstGeom>
+          <a:noFill/>
+        </p:spPr>
+        <p:txBody>
+          <a:bodyPr wrap="none">
+            <a:spAutoFit/>
+          </a:bodyPr>
+          <a:lstStyle/>
+          <a:p>
+            <a:pPr>
+              <a:defRPr sz="800">
+                <a:solidFill>
+                  <a:srgbClr val="667487"/>
+                </a:solidFill>
+              </a:defRPr>
+            </a:pPr>
+            <a:r>
+              <a:t>Elastic Payments Analytics Demo</a:t>
+            </a:r>
+          </a:p>
+        </p:txBody>
+      </p:sp>
+      <p:sp>
+        <p:nvSpPr>
+          <p:cNvPr id="6" name="TextBox 5"/>
+          <p:cNvSpPr txBox="1"/>
+          <p:nvPr/>
+        </p:nvSpPr>
+        <p:spPr>
+          <a:xfrm>
+            <a:off x="9326880" y="6446520"/>
+            <a:ext cx="2377440" cy="228600"/>
+          </a:xfrm>
+          <a:prstGeom prst="rect">
+            <a:avLst/>
+          </a:prstGeom>
+          <a:noFill/>
+        </p:spPr>
+        <p:txBody>
+          <a:bodyPr wrap="none">
+            <a:spAutoFit/>
+          </a:bodyPr>
+          <a:lstStyle/>
+          <a:p>
+            <a:pPr algn="r">
+              <a:defRPr sz="800">
+                <a:solidFill>
+                  <a:srgbClr val="667487"/>
+                </a:solidFill>
+              </a:defRPr>
+            </a:pPr>
+            <a:r>
+              <a:t>Jun 09, 2026</a:t>
+            </a:r>
+          </a:p>
+        </p:txBody>
+      </p:sp>
+      <p:sp>
+        <p:nvSpPr>
+          <p:cNvPr id="7" name="Rounded Rectangle 6"/>
+          <p:cNvSpPr/>
+          <p:nvPr/>
+        </p:nvSpPr>
+        <p:spPr>
+          <a:xfrm>
+            <a:off x="502920" y="1234440"/>
+            <a:ext cx="1737360" cy="1005840"/>
+          </a:xfrm>
+          <a:prstGeom prst="roundRect">
+            <a:avLst/>
+          </a:prstGeom>
+          <a:solidFill>
+            <a:srgbClr val="FFFFFF"/>
+          </a:solidFill>
+          <a:ln>
+            <a:solidFill>
+              <a:srgbClr val="D2DDEB"/>
+            </a:solidFill>
+          </a:ln>
+        </p:spPr>
+        <p:style>
+          <a:lnRef idx="1">
+            <a:schemeClr val="accent1"/>
+          </a:lnRef>
+          <a:fillRef idx="3">
+            <a:schemeClr val="accent1"/>
+          </a:fillRef>
+          <a:effectRef idx="2">
+            <a:schemeClr val="accent1"/>
+          </a:effectRef>
+          <a:fontRef idx="minor">
+            <a:schemeClr val="lt1"/>
+          </a:fontRef>
+        </p:style>
+        <p:txBody>
+          <a:bodyPr rtlCol="0" anchor="ctr"/>
+          <a:lstStyle/>
+          <a:p>
+            <a:pPr algn="ctr"/>
+          </a:p>
+        </p:txBody>
+      </p:sp>
+      <p:sp>
+        <p:nvSpPr>
+          <p:cNvPr id="8" name="Rectangle 7"/>
+          <p:cNvSpPr/>
+          <p:nvPr/>
+        </p:nvSpPr>
+        <p:spPr>
+          <a:xfrm>
+            <a:off x="502920" y="1234440"/>
+            <a:ext cx="73152" cy="1005840"/>
+          </a:xfrm>
+          <a:prstGeom prst="rect">
+            <a:avLst/>
+          </a:prstGeom>
+          <a:solidFill>
+            <a:srgbClr val="44AA5C"/>
+          </a:solidFill>
+          <a:ln>
+            <a:noFill/>
+          </a:ln>
+        </p:spPr>
+        <p:style>
+          <a:lnRef idx="1">
+            <a:schemeClr val="accent1"/>
+          </a:lnRef>
+          <a:fillRef idx="3">
+            <a:schemeClr val="accent1"/>
+          </a:fillRef>
+          <a:effectRef idx="2">
+            <a:schemeClr val="accent1"/>
+          </a:effectRef>
+          <a:fontRef idx="minor">
+            <a:schemeClr val="lt1"/>
+          </a:fontRef>
+        </p:style>
+        <p:txBody>
+          <a:bodyPr rtlCol="0" anchor="ctr"/>
+          <a:lstStyle/>
+          <a:p>
+            <a:pPr algn="ctr"/>
+          </a:p>
+        </p:txBody>
+      </p:sp>
+      <p:sp>
+        <p:nvSpPr>
+          <p:cNvPr id="9" name="TextBox 8"/>
+          <p:cNvSpPr txBox="1"/>
+          <p:nvPr/>
+        </p:nvSpPr>
+        <p:spPr>
+          <a:xfrm>
+            <a:off x="704088" y="1371600"/>
+            <a:ext cx="1417319" cy="274320"/>
+          </a:xfrm>
+          <a:prstGeom prst="rect">
+            <a:avLst/>
+          </a:prstGeom>
+          <a:noFill/>
+        </p:spPr>
+        <p:txBody>
+          <a:bodyPr wrap="none">
+            <a:spAutoFit/>
+          </a:bodyPr>
+          <a:lstStyle/>
+          <a:p>
+            <a:pPr>
+              <a:defRPr sz="1000" b="1">
+                <a:solidFill>
+                  <a:srgbClr val="667487"/>
+                </a:solidFill>
+              </a:defRPr>
+            </a:pPr>
+            <a:r>
+              <a:t>Availability SLI</a:t>
+            </a:r>
+          </a:p>
+        </p:txBody>
+      </p:sp>
+      <p:sp>
+        <p:nvSpPr>
+          <p:cNvPr id="10" name="TextBox 9"/>
+          <p:cNvSpPr txBox="1"/>
+          <p:nvPr/>
+        </p:nvSpPr>
+        <p:spPr>
+          <a:xfrm>
+            <a:off x="704088" y="1673352"/>
+            <a:ext cx="1417319" cy="502920"/>
+          </a:xfrm>
+          <a:prstGeom prst="rect">
+            <a:avLst/>
+          </a:prstGeom>
+          <a:noFill/>
+        </p:spPr>
+        <p:txBody>
+          <a:bodyPr wrap="none">
+            <a:spAutoFit/>
+          </a:bodyPr>
+          <a:lstStyle/>
+          <a:p>
+            <a:pPr>
+              <a:defRPr sz="2200" b="1">
+                <a:solidFill>
+                  <a:srgbClr val="142440"/>
+                </a:solidFill>
+              </a:defRPr>
+            </a:pPr>
+            <a:r>
+              <a:t>94.81%</a:t>
+            </a:r>
+          </a:p>
+        </p:txBody>
+      </p:sp>
+      <p:sp>
+        <p:nvSpPr>
+          <p:cNvPr id="11" name="Rounded Rectangle 10"/>
+          <p:cNvSpPr/>
+          <p:nvPr/>
+        </p:nvSpPr>
+        <p:spPr>
+          <a:xfrm>
+            <a:off x="2423160" y="1234440"/>
+            <a:ext cx="1737360" cy="1005840"/>
+          </a:xfrm>
+          <a:prstGeom prst="roundRect">
+            <a:avLst/>
+          </a:prstGeom>
+          <a:solidFill>
+            <a:srgbClr val="FFFFFF"/>
+          </a:solidFill>
+          <a:ln>
+            <a:solidFill>
+              <a:srgbClr val="D2DDEB"/>
+            </a:solidFill>
+          </a:ln>
+        </p:spPr>
+        <p:style>
+          <a:lnRef idx="1">
+            <a:schemeClr val="accent1"/>
+          </a:lnRef>
+          <a:fillRef idx="3">
+            <a:schemeClr val="accent1"/>
+          </a:fillRef>
+          <a:effectRef idx="2">
+            <a:schemeClr val="accent1"/>
+          </a:effectRef>
+          <a:fontRef idx="minor">
+            <a:schemeClr val="lt1"/>
+          </a:fontRef>
+        </p:style>
+        <p:txBody>
+          <a:bodyPr rtlCol="0" anchor="ctr"/>
+          <a:lstStyle/>
+          <a:p>
+            <a:pPr algn="ctr"/>
+          </a:p>
+        </p:txBody>
+      </p:sp>
+      <p:sp>
+        <p:nvSpPr>
+          <p:cNvPr id="12" name="Rectangle 11"/>
+          <p:cNvSpPr/>
+          <p:nvPr/>
+        </p:nvSpPr>
+        <p:spPr>
+          <a:xfrm>
+            <a:off x="2423160" y="1234440"/>
+            <a:ext cx="73152" cy="1005840"/>
+          </a:xfrm>
+          <a:prstGeom prst="rect">
+            <a:avLst/>
+          </a:prstGeom>
+          <a:solidFill>
+            <a:srgbClr val="EF8438"/>
+          </a:solidFill>
+          <a:ln>
+            <a:noFill/>
+          </a:ln>
+        </p:spPr>
+        <p:style>
+          <a:lnRef idx="1">
+            <a:schemeClr val="accent1"/>
+          </a:lnRef>
+          <a:fillRef idx="3">
+            <a:schemeClr val="accent1"/>
+          </a:fillRef>
+          <a:effectRef idx="2">
+            <a:schemeClr val="accent1"/>
+          </a:effectRef>
+          <a:fontRef idx="minor">
+            <a:schemeClr val="lt1"/>
+          </a:fontRef>
+        </p:style>
+        <p:txBody>
+          <a:bodyPr rtlCol="0" anchor="ctr"/>
+          <a:lstStyle/>
+          <a:p>
+            <a:pPr algn="ctr"/>
+          </a:p>
+        </p:txBody>
+      </p:sp>
+      <p:sp>
+        <p:nvSpPr>
+          <p:cNvPr id="13" name="TextBox 12"/>
+          <p:cNvSpPr txBox="1"/>
+          <p:nvPr/>
+        </p:nvSpPr>
+        <p:spPr>
+          <a:xfrm>
+            <a:off x="2624328" y="1371600"/>
+            <a:ext cx="1417319" cy="274320"/>
+          </a:xfrm>
+          <a:prstGeom prst="rect">
+            <a:avLst/>
+          </a:prstGeom>
+          <a:noFill/>
+        </p:spPr>
+        <p:txBody>
+          <a:bodyPr wrap="none">
+            <a:spAutoFit/>
+          </a:bodyPr>
+          <a:lstStyle/>
+          <a:p>
+            <a:pPr>
+              <a:defRPr sz="1000" b="1">
+                <a:solidFill>
+                  <a:srgbClr val="667487"/>
+                </a:solidFill>
+              </a:defRPr>
+            </a:pPr>
+            <a:r>
+              <a:t>Failure Rate</a:t>
+            </a:r>
+          </a:p>
+        </p:txBody>
+      </p:sp>
+      <p:sp>
+        <p:nvSpPr>
+          <p:cNvPr id="14" name="TextBox 13"/>
+          <p:cNvSpPr txBox="1"/>
+          <p:nvPr/>
+        </p:nvSpPr>
+        <p:spPr>
+          <a:xfrm>
+            <a:off x="2624328" y="1673352"/>
+            <a:ext cx="1417319" cy="502920"/>
+          </a:xfrm>
+          <a:prstGeom prst="rect">
+            <a:avLst/>
+          </a:prstGeom>
+          <a:noFill/>
+        </p:spPr>
+        <p:txBody>
+          <a:bodyPr wrap="none">
+            <a:spAutoFit/>
+          </a:bodyPr>
+          <a:lstStyle/>
+          <a:p>
+            <a:pPr>
+              <a:defRPr sz="2200" b="1">
+                <a:solidFill>
+                  <a:srgbClr val="142440"/>
+                </a:solidFill>
+              </a:defRPr>
+            </a:pPr>
+            <a:r>
+              <a:t>5.19%</a:t>
+            </a:r>
+          </a:p>
+        </p:txBody>
+      </p:sp>
+      <p:sp>
+        <p:nvSpPr>
+          <p:cNvPr id="15" name="Rounded Rectangle 14"/>
+          <p:cNvSpPr/>
+          <p:nvPr/>
+        </p:nvSpPr>
+        <p:spPr>
+          <a:xfrm>
+            <a:off x="4343400" y="1234440"/>
+            <a:ext cx="1737360" cy="1005840"/>
+          </a:xfrm>
+          <a:prstGeom prst="roundRect">
+            <a:avLst/>
+          </a:prstGeom>
+          <a:solidFill>
+            <a:srgbClr val="FFFFFF"/>
+          </a:solidFill>
+          <a:ln>
+            <a:solidFill>
+              <a:srgbClr val="D2DDEB"/>
+            </a:solidFill>
+          </a:ln>
+        </p:spPr>
+        <p:style>
+          <a:lnRef idx="1">
+            <a:schemeClr val="accent1"/>
+          </a:lnRef>
+          <a:fillRef idx="3">
+            <a:schemeClr val="accent1"/>
+          </a:fillRef>
+          <a:effectRef idx="2">
+            <a:schemeClr val="accent1"/>
+          </a:effectRef>
+          <a:fontRef idx="minor">
+            <a:schemeClr val="lt1"/>
+          </a:fontRef>
+        </p:style>
+        <p:txBody>
+          <a:bodyPr rtlCol="0" anchor="ctr"/>
+          <a:lstStyle/>
+          <a:p>
+            <a:pPr algn="ctr"/>
+          </a:p>
+        </p:txBody>
+      </p:sp>
+      <p:sp>
+        <p:nvSpPr>
+          <p:cNvPr id="16" name="Rectangle 15"/>
+          <p:cNvSpPr/>
+          <p:nvPr/>
+        </p:nvSpPr>
+        <p:spPr>
+          <a:xfrm>
+            <a:off x="4343400" y="1234440"/>
+            <a:ext cx="73152" cy="1005840"/>
+          </a:xfrm>
+          <a:prstGeom prst="rect">
+            <a:avLst/>
+          </a:prstGeom>
+          <a:solidFill>
+            <a:srgbClr val="3673C8"/>
+          </a:solidFill>
+          <a:ln>
+            <a:noFill/>
+          </a:ln>
+        </p:spPr>
+        <p:style>
+          <a:lnRef idx="1">
+            <a:schemeClr val="accent1"/>
+          </a:lnRef>
+          <a:fillRef idx="3">
+            <a:schemeClr val="accent1"/>
+          </a:fillRef>
+          <a:effectRef idx="2">
+            <a:schemeClr val="accent1"/>
+          </a:effectRef>
+          <a:fontRef idx="minor">
+            <a:schemeClr val="lt1"/>
+          </a:fontRef>
+        </p:style>
+        <p:txBody>
+          <a:bodyPr rtlCol="0" anchor="ctr"/>
+          <a:lstStyle/>
+          <a:p>
+            <a:pPr algn="ctr"/>
+          </a:p>
+        </p:txBody>
+      </p:sp>
+      <p:sp>
+        <p:nvSpPr>
+          <p:cNvPr id="17" name="TextBox 16"/>
+          <p:cNvSpPr txBox="1"/>
+          <p:nvPr/>
+        </p:nvSpPr>
+        <p:spPr>
+          <a:xfrm>
+            <a:off x="4544568" y="1371600"/>
+            <a:ext cx="1417319" cy="274320"/>
+          </a:xfrm>
+          <a:prstGeom prst="rect">
+            <a:avLst/>
+          </a:prstGeom>
+          <a:noFill/>
+        </p:spPr>
+        <p:txBody>
+          <a:bodyPr wrap="none">
+            <a:spAutoFit/>
+          </a:bodyPr>
+          <a:lstStyle/>
+          <a:p>
+            <a:pPr>
+              <a:defRPr sz="1000" b="1">
+                <a:solidFill>
+                  <a:srgbClr val="667487"/>
+                </a:solidFill>
+              </a:defRPr>
+            </a:pPr>
+            <a:r>
+              <a:t>P95 Latency</a:t>
+            </a:r>
+          </a:p>
+        </p:txBody>
+      </p:sp>
+      <p:sp>
+        <p:nvSpPr>
+          <p:cNvPr id="18" name="TextBox 17"/>
+          <p:cNvSpPr txBox="1"/>
+          <p:nvPr/>
+        </p:nvSpPr>
+        <p:spPr>
+          <a:xfrm>
+            <a:off x="4544568" y="1673352"/>
+            <a:ext cx="1417319" cy="502920"/>
+          </a:xfrm>
+          <a:prstGeom prst="rect">
+            <a:avLst/>
+          </a:prstGeom>
+          <a:noFill/>
+        </p:spPr>
+        <p:txBody>
+          <a:bodyPr wrap="none">
+            <a:spAutoFit/>
+          </a:bodyPr>
+          <a:lstStyle/>
+          <a:p>
+            <a:pPr>
+              <a:defRPr sz="2200" b="1">
+                <a:solidFill>
+                  <a:srgbClr val="142440"/>
+                </a:solidFill>
+              </a:defRPr>
+            </a:pPr>
+            <a:r>
+              <a:t>2,376 ms</a:t>
+            </a:r>
+          </a:p>
+        </p:txBody>
+      </p:sp>
+      <p:sp>
+        <p:nvSpPr>
+          <p:cNvPr id="19" name="Rounded Rectangle 18"/>
+          <p:cNvSpPr/>
+          <p:nvPr/>
+        </p:nvSpPr>
+        <p:spPr>
+          <a:xfrm>
+            <a:off x="6263640" y="1234440"/>
+            <a:ext cx="1737360" cy="1005840"/>
+          </a:xfrm>
+          <a:prstGeom prst="roundRect">
+            <a:avLst/>
+          </a:prstGeom>
+          <a:solidFill>
+            <a:srgbClr val="FFFFFF"/>
+          </a:solidFill>
+          <a:ln>
+            <a:solidFill>
+              <a:srgbClr val="D2DDEB"/>
+            </a:solidFill>
+          </a:ln>
+        </p:spPr>
+        <p:style>
+          <a:lnRef idx="1">
+            <a:schemeClr val="accent1"/>
+          </a:lnRef>
+          <a:fillRef idx="3">
+            <a:schemeClr val="accent1"/>
+          </a:fillRef>
+          <a:effectRef idx="2">
+            <a:schemeClr val="accent1"/>
+          </a:effectRef>
+          <a:fontRef idx="minor">
+            <a:schemeClr val="lt1"/>
+          </a:fontRef>
+        </p:style>
+        <p:txBody>
+          <a:bodyPr rtlCol="0" anchor="ctr"/>
+          <a:lstStyle/>
+          <a:p>
+            <a:pPr algn="ctr"/>
+          </a:p>
+        </p:txBody>
+      </p:sp>
+      <p:sp>
+        <p:nvSpPr>
+          <p:cNvPr id="20" name="Rectangle 19"/>
+          <p:cNvSpPr/>
+          <p:nvPr/>
+        </p:nvSpPr>
+        <p:spPr>
+          <a:xfrm>
+            <a:off x="6263640" y="1234440"/>
+            <a:ext cx="73152" cy="1005840"/>
+          </a:xfrm>
+          <a:prstGeom prst="rect">
+            <a:avLst/>
+          </a:prstGeom>
+          <a:solidFill>
+            <a:srgbClr val="7058BE"/>
+          </a:solidFill>
+          <a:ln>
+            <a:noFill/>
+          </a:ln>
+        </p:spPr>
+        <p:style>
+          <a:lnRef idx="1">
+            <a:schemeClr val="accent1"/>
+          </a:lnRef>
+          <a:fillRef idx="3">
+            <a:schemeClr val="accent1"/>
+          </a:fillRef>
+          <a:effectRef idx="2">
+            <a:schemeClr val="accent1"/>
+          </a:effectRef>
+          <a:fontRef idx="minor">
+            <a:schemeClr val="lt1"/>
+          </a:fontRef>
+        </p:style>
+        <p:txBody>
+          <a:bodyPr rtlCol="0" anchor="ctr"/>
+          <a:lstStyle/>
+          <a:p>
+            <a:pPr algn="ctr"/>
+          </a:p>
+        </p:txBody>
+      </p:sp>
+      <p:sp>
+        <p:nvSpPr>
+          <p:cNvPr id="21" name="TextBox 20"/>
+          <p:cNvSpPr txBox="1"/>
+          <p:nvPr/>
+        </p:nvSpPr>
+        <p:spPr>
+          <a:xfrm>
+            <a:off x="6464808" y="1371600"/>
+            <a:ext cx="1417319" cy="274320"/>
+          </a:xfrm>
+          <a:prstGeom prst="rect">
+            <a:avLst/>
+          </a:prstGeom>
+          <a:noFill/>
+        </p:spPr>
+        <p:txBody>
+          <a:bodyPr wrap="none">
+            <a:spAutoFit/>
+          </a:bodyPr>
+          <a:lstStyle/>
+          <a:p>
+            <a:pPr>
+              <a:defRPr sz="1000" b="1">
+                <a:solidFill>
+                  <a:srgbClr val="667487"/>
+                </a:solidFill>
+              </a:defRPr>
+            </a:pPr>
+            <a:r>
+              <a:t>P99 Latency</a:t>
+            </a:r>
+          </a:p>
+        </p:txBody>
+      </p:sp>
+      <p:sp>
+        <p:nvSpPr>
+          <p:cNvPr id="22" name="TextBox 21"/>
+          <p:cNvSpPr txBox="1"/>
+          <p:nvPr/>
+        </p:nvSpPr>
+        <p:spPr>
+          <a:xfrm>
+            <a:off x="6464808" y="1673352"/>
+            <a:ext cx="1417319" cy="502920"/>
+          </a:xfrm>
+          <a:prstGeom prst="rect">
+            <a:avLst/>
+          </a:prstGeom>
+          <a:noFill/>
+        </p:spPr>
+        <p:txBody>
+          <a:bodyPr wrap="none">
+            <a:spAutoFit/>
+          </a:bodyPr>
+          <a:lstStyle/>
+          <a:p>
+            <a:pPr>
+              <a:defRPr sz="2200" b="1">
+                <a:solidFill>
+                  <a:srgbClr val="142440"/>
+                </a:solidFill>
+              </a:defRPr>
+            </a:pPr>
+            <a:r>
+              <a:t>2,475 ms</a:t>
+            </a:r>
+          </a:p>
+        </p:txBody>
+      </p:sp>
+      <p:sp>
+        <p:nvSpPr>
+          <p:cNvPr id="23" name="Rounded Rectangle 22"/>
+          <p:cNvSpPr/>
+          <p:nvPr/>
+        </p:nvSpPr>
+        <p:spPr>
+          <a:xfrm>
+            <a:off x="8183880" y="1234440"/>
+            <a:ext cx="1737360" cy="1005840"/>
+          </a:xfrm>
+          <a:prstGeom prst="roundRect">
+            <a:avLst/>
+          </a:prstGeom>
+          <a:solidFill>
+            <a:srgbClr val="FFFFFF"/>
+          </a:solidFill>
+          <a:ln>
+            <a:solidFill>
+              <a:srgbClr val="D2DDEB"/>
+            </a:solidFill>
+          </a:ln>
+        </p:spPr>
+        <p:style>
+          <a:lnRef idx="1">
+            <a:schemeClr val="accent1"/>
+          </a:lnRef>
+          <a:fillRef idx="3">
+            <a:schemeClr val="accent1"/>
+          </a:fillRef>
+          <a:effectRef idx="2">
+            <a:schemeClr val="accent1"/>
+          </a:effectRef>
+          <a:fontRef idx="minor">
+            <a:schemeClr val="lt1"/>
+          </a:fontRef>
+        </p:style>
+        <p:txBody>
+          <a:bodyPr rtlCol="0" anchor="ctr"/>
+          <a:lstStyle/>
+          <a:p>
+            <a:pPr algn="ctr"/>
+          </a:p>
+        </p:txBody>
+      </p:sp>
+      <p:sp>
+        <p:nvSpPr>
+          <p:cNvPr id="24" name="Rectangle 23"/>
+          <p:cNvSpPr/>
+          <p:nvPr/>
+        </p:nvSpPr>
+        <p:spPr>
+          <a:xfrm>
+            <a:off x="8183880" y="1234440"/>
+            <a:ext cx="73152" cy="1005840"/>
+          </a:xfrm>
+          <a:prstGeom prst="rect">
+            <a:avLst/>
+          </a:prstGeom>
+          <a:solidFill>
+            <a:srgbClr val="00959C"/>
+          </a:solidFill>
+          <a:ln>
+            <a:noFill/>
+          </a:ln>
+        </p:spPr>
+        <p:style>
+          <a:lnRef idx="1">
+            <a:schemeClr val="accent1"/>
+          </a:lnRef>
+          <a:fillRef idx="3">
+            <a:schemeClr val="accent1"/>
+          </a:fillRef>
+          <a:effectRef idx="2">
+            <a:schemeClr val="accent1"/>
+          </a:effectRef>
+          <a:fontRef idx="minor">
+            <a:schemeClr val="lt1"/>
+          </a:fontRef>
+        </p:style>
+        <p:txBody>
+          <a:bodyPr rtlCol="0" anchor="ctr"/>
+          <a:lstStyle/>
+          <a:p>
+            <a:pPr algn="ctr"/>
+          </a:p>
+        </p:txBody>
+      </p:sp>
+      <p:sp>
+        <p:nvSpPr>
+          <p:cNvPr id="25" name="TextBox 24"/>
+          <p:cNvSpPr txBox="1"/>
+          <p:nvPr/>
+        </p:nvSpPr>
+        <p:spPr>
+          <a:xfrm>
+            <a:off x="8385048" y="1371600"/>
+            <a:ext cx="1417319" cy="274320"/>
+          </a:xfrm>
+          <a:prstGeom prst="rect">
+            <a:avLst/>
+          </a:prstGeom>
+          <a:noFill/>
+        </p:spPr>
+        <p:txBody>
+          <a:bodyPr wrap="none">
+            <a:spAutoFit/>
+          </a:bodyPr>
+          <a:lstStyle/>
+          <a:p>
+            <a:pPr>
+              <a:defRPr sz="1000" b="1">
+                <a:solidFill>
+                  <a:srgbClr val="667487"/>
+                </a:solidFill>
+              </a:defRPr>
+            </a:pPr>
+            <a:r>
+              <a:t>Latency SLO &lt;=2s</a:t>
+            </a:r>
+          </a:p>
+        </p:txBody>
+      </p:sp>
+      <p:sp>
+        <p:nvSpPr>
+          <p:cNvPr id="26" name="TextBox 25"/>
+          <p:cNvSpPr txBox="1"/>
+          <p:nvPr/>
+        </p:nvSpPr>
+        <p:spPr>
+          <a:xfrm>
+            <a:off x="8385048" y="1673352"/>
+            <a:ext cx="1417319" cy="502920"/>
+          </a:xfrm>
+          <a:prstGeom prst="rect">
+            <a:avLst/>
+          </a:prstGeom>
+          <a:noFill/>
+        </p:spPr>
+        <p:txBody>
+          <a:bodyPr wrap="none">
+            <a:spAutoFit/>
+          </a:bodyPr>
+          <a:lstStyle/>
+          <a:p>
+            <a:pPr>
+              <a:defRPr sz="2200" b="1">
+                <a:solidFill>
+                  <a:srgbClr val="142440"/>
+                </a:solidFill>
+              </a:defRPr>
+            </a:pPr>
+            <a:r>
+              <a:t>79.89%</a:t>
+            </a:r>
+          </a:p>
+        </p:txBody>
+      </p:sp>
+      <p:sp>
+        <p:nvSpPr>
+          <p:cNvPr id="27" name="Rounded Rectangle 26"/>
+          <p:cNvSpPr/>
+          <p:nvPr/>
+        </p:nvSpPr>
+        <p:spPr>
+          <a:xfrm>
+            <a:off x="10104120" y="1234440"/>
+            <a:ext cx="1737360" cy="1005840"/>
+          </a:xfrm>
+          <a:prstGeom prst="roundRect">
+            <a:avLst/>
+          </a:prstGeom>
+          <a:solidFill>
+            <a:srgbClr val="FFFFFF"/>
+          </a:solidFill>
+          <a:ln>
+            <a:solidFill>
+              <a:srgbClr val="D2DDEB"/>
+            </a:solidFill>
+          </a:ln>
+        </p:spPr>
+        <p:style>
+          <a:lnRef idx="1">
+            <a:schemeClr val="accent1"/>
+          </a:lnRef>
+          <a:fillRef idx="3">
+            <a:schemeClr val="accent1"/>
+          </a:fillRef>
+          <a:effectRef idx="2">
+            <a:schemeClr val="accent1"/>
+          </a:effectRef>
+          <a:fontRef idx="minor">
+            <a:schemeClr val="lt1"/>
+          </a:fontRef>
+        </p:style>
+        <p:txBody>
+          <a:bodyPr rtlCol="0" anchor="ctr"/>
+          <a:lstStyle/>
+          <a:p>
+            <a:pPr algn="ctr"/>
+          </a:p>
+        </p:txBody>
+      </p:sp>
+      <p:sp>
+        <p:nvSpPr>
+          <p:cNvPr id="28" name="Rectangle 27"/>
+          <p:cNvSpPr/>
+          <p:nvPr/>
+        </p:nvSpPr>
+        <p:spPr>
+          <a:xfrm>
+            <a:off x="10104120" y="1234440"/>
+            <a:ext cx="73152" cy="1005840"/>
+          </a:xfrm>
+          <a:prstGeom prst="rect">
+            <a:avLst/>
+          </a:prstGeom>
+          <a:solidFill>
+            <a:srgbClr val="D24848"/>
+          </a:solidFill>
+          <a:ln>
+            <a:noFill/>
+          </a:ln>
+        </p:spPr>
+        <p:style>
+          <a:lnRef idx="1">
+            <a:schemeClr val="accent1"/>
+          </a:lnRef>
+          <a:fillRef idx="3">
+            <a:schemeClr val="accent1"/>
+          </a:fillRef>
+          <a:effectRef idx="2">
+            <a:schemeClr val="accent1"/>
+          </a:effectRef>
+          <a:fontRef idx="minor">
+            <a:schemeClr val="lt1"/>
+          </a:fontRef>
+        </p:style>
+        <p:txBody>
+          <a:bodyPr rtlCol="0" anchor="ctr"/>
+          <a:lstStyle/>
+          <a:p>
+            <a:pPr algn="ctr"/>
+          </a:p>
+        </p:txBody>
+      </p:sp>
+      <p:sp>
+        <p:nvSpPr>
+          <p:cNvPr id="29" name="TextBox 28"/>
+          <p:cNvSpPr txBox="1"/>
+          <p:nvPr/>
+        </p:nvSpPr>
+        <p:spPr>
+          <a:xfrm>
+            <a:off x="10305288" y="1371600"/>
+            <a:ext cx="1417319" cy="274320"/>
+          </a:xfrm>
+          <a:prstGeom prst="rect">
+            <a:avLst/>
+          </a:prstGeom>
+          <a:noFill/>
+        </p:spPr>
+        <p:txBody>
+          <a:bodyPr wrap="none">
+            <a:spAutoFit/>
+          </a:bodyPr>
+          <a:lstStyle/>
+          <a:p>
+            <a:pPr>
+              <a:defRPr sz="1000" b="1">
+                <a:solidFill>
+                  <a:srgbClr val="667487"/>
+                </a:solidFill>
+              </a:defRPr>
+            </a:pPr>
+            <a:r>
+              <a:t>Error Log Events</a:t>
+            </a:r>
+          </a:p>
+        </p:txBody>
+      </p:sp>
+      <p:sp>
+        <p:nvSpPr>
+          <p:cNvPr id="30" name="TextBox 29"/>
+          <p:cNvSpPr txBox="1"/>
+          <p:nvPr/>
+        </p:nvSpPr>
+        <p:spPr>
+          <a:xfrm>
+            <a:off x="10305288" y="1673352"/>
+            <a:ext cx="1417319" cy="502920"/>
+          </a:xfrm>
+          <a:prstGeom prst="rect">
+            <a:avLst/>
+          </a:prstGeom>
+          <a:noFill/>
+        </p:spPr>
+        <p:txBody>
+          <a:bodyPr wrap="none">
+            <a:spAutoFit/>
+          </a:bodyPr>
+          <a:lstStyle/>
+          <a:p>
+            <a:pPr>
+              <a:defRPr sz="2200" b="1">
+                <a:solidFill>
+                  <a:srgbClr val="142440"/>
+                </a:solidFill>
+              </a:defRPr>
+            </a:pPr>
+            <a:r>
+              <a:t>51,887</a:t>
+            </a:r>
+          </a:p>
+        </p:txBody>
+      </p:sp>
+      <p:sp>
+        <p:nvSpPr>
+          <p:cNvPr id="31" name="TextBox 30"/>
+          <p:cNvSpPr txBox="1"/>
+          <p:nvPr/>
+        </p:nvSpPr>
+        <p:spPr>
+          <a:xfrm>
+            <a:off x="822960" y="2788920"/>
+            <a:ext cx="5212080" cy="2377440"/>
+          </a:xfrm>
+          <a:prstGeom prst="rect">
+            <a:avLst/>
+          </a:prstGeom>
+          <a:noFill/>
+        </p:spPr>
+        <p:txBody>
+          <a:bodyPr wrap="square">
+            <a:spAutoFit/>
+          </a:bodyPr>
+          <a:lstStyle/>
+          <a:p>
+            <a:pPr>
+              <a:buChar char="•"/>
+              <a:spcAft>
+                <a:spcPts val="800"/>
+              </a:spcAft>
+              <a:defRPr sz="1400">
+                <a:solidFill>
+                  <a:srgbClr val="222D3D"/>
+                </a:solidFill>
+              </a:defRPr>
+            </a:pPr>
+            <a:r>
+              <a:t>Treats each payment transaction as a service event for payments-api.</a:t>
+            </a:r>
+          </a:p>
+          <a:p>
+            <a:pPr>
+              <a:buChar char="•"/>
+              <a:spcAft>
+                <a:spcPts val="800"/>
+              </a:spcAft>
+              <a:defRPr sz="1400">
+                <a:solidFill>
+                  <a:srgbClr val="222D3D"/>
+                </a:solidFill>
+              </a:defRPr>
+            </a:pPr>
+            <a:r>
+              <a:t>Shows throughput, failure-rate and latency trends over time.</a:t>
+            </a:r>
+          </a:p>
+          <a:p>
+            <a:pPr>
+              <a:buChar char="•"/>
+              <a:spcAft>
+                <a:spcPts val="800"/>
+              </a:spcAft>
+              <a:defRPr sz="1400">
+                <a:solidFill>
+                  <a:srgbClr val="222D3D"/>
+                </a:solidFill>
+              </a:defRPr>
+            </a:pPr>
+            <a:r>
+              <a:t>Uses error_message as application log events for troubleshooting.</a:t>
+            </a:r>
+          </a:p>
+          <a:p>
+            <a:pPr>
+              <a:buChar char="•"/>
+              <a:spcAft>
+                <a:spcPts val="800"/>
+              </a:spcAft>
+              <a:defRPr sz="1400">
+                <a:solidFill>
+                  <a:srgbClr val="222D3D"/>
+                </a:solidFill>
+              </a:defRPr>
+            </a:pPr>
+            <a:r>
+              <a:t>Includes trace-style drill-down for slowest and failed transactions.</a:t>
+            </a:r>
+          </a:p>
+        </p:txBody>
+      </p:sp>
+      <p:sp>
+        <p:nvSpPr>
+          <p:cNvPr id="32" name="Rounded Rectangle 31"/>
+          <p:cNvSpPr/>
+          <p:nvPr/>
+        </p:nvSpPr>
+        <p:spPr>
+          <a:xfrm>
+            <a:off x="6400800" y="2788920"/>
+            <a:ext cx="4663440" cy="2240280"/>
+          </a:xfrm>
+          <a:prstGeom prst="roundRect">
+            <a:avLst/>
+          </a:prstGeom>
+          <a:solidFill>
+            <a:srgbClr val="FFFFFF"/>
+          </a:solidFill>
+          <a:ln>
+            <a:solidFill>
+              <a:srgbClr val="D2DDEB"/>
+            </a:solidFill>
+          </a:ln>
+        </p:spPr>
+        <p:style>
+          <a:lnRef idx="1">
+            <a:schemeClr val="accent1"/>
+          </a:lnRef>
+          <a:fillRef idx="3">
+            <a:schemeClr val="accent1"/>
+          </a:fillRef>
+          <a:effectRef idx="2">
+            <a:schemeClr val="accent1"/>
+          </a:effectRef>
+          <a:fontRef idx="minor">
+            <a:schemeClr val="lt1"/>
+          </a:fontRef>
+        </p:style>
+        <p:txBody>
+          <a:bodyPr rtlCol="0" anchor="ctr"/>
+          <a:lstStyle/>
+          <a:p>
+            <a:pPr algn="ctr"/>
+          </a:p>
+        </p:txBody>
+      </p:sp>
+      <p:sp>
+        <p:nvSpPr>
+          <p:cNvPr id="33" name="Rectangle 32"/>
+          <p:cNvSpPr/>
+          <p:nvPr/>
+        </p:nvSpPr>
+        <p:spPr>
+          <a:xfrm>
+            <a:off x="6400800" y="2788920"/>
+            <a:ext cx="73152" cy="2240280"/>
+          </a:xfrm>
+          <a:prstGeom prst="rect">
+            <a:avLst/>
+          </a:prstGeom>
+          <a:solidFill>
+            <a:srgbClr val="00959C"/>
+          </a:solidFill>
+          <a:ln>
+            <a:noFill/>
+          </a:ln>
+        </p:spPr>
+        <p:style>
+          <a:lnRef idx="1">
+            <a:schemeClr val="accent1"/>
+          </a:lnRef>
+          <a:fillRef idx="3">
+            <a:schemeClr val="accent1"/>
+          </a:fillRef>
+          <a:effectRef idx="2">
+            <a:schemeClr val="accent1"/>
+          </a:effectRef>
+          <a:fontRef idx="minor">
+            <a:schemeClr val="lt1"/>
+          </a:fontRef>
+        </p:style>
+        <p:txBody>
+          <a:bodyPr rtlCol="0" anchor="ctr"/>
+          <a:lstStyle/>
+          <a:p>
+            <a:pPr algn="ctr"/>
+          </a:p>
+        </p:txBody>
+      </p:sp>
+      <p:sp>
+        <p:nvSpPr>
+          <p:cNvPr id="34" name="TextBox 33"/>
+          <p:cNvSpPr txBox="1"/>
+          <p:nvPr/>
+        </p:nvSpPr>
+        <p:spPr>
+          <a:xfrm>
+            <a:off x="6601968" y="2926079"/>
+            <a:ext cx="4343400" cy="274320"/>
+          </a:xfrm>
+          <a:prstGeom prst="rect">
+            <a:avLst/>
+          </a:prstGeom>
+          <a:noFill/>
+        </p:spPr>
+        <p:txBody>
+          <a:bodyPr wrap="none">
+            <a:spAutoFit/>
+          </a:bodyPr>
+          <a:lstStyle/>
+          <a:p>
+            <a:pPr>
+              <a:defRPr sz="1000" b="1">
+                <a:solidFill>
+                  <a:srgbClr val="667487"/>
+                </a:solidFill>
+              </a:defRPr>
+            </a:pPr>
+            <a:r>
+              <a:t>Production extension</a:t>
+            </a:r>
+          </a:p>
+        </p:txBody>
+      </p:sp>
+      <p:sp>
+        <p:nvSpPr>
+          <p:cNvPr id="35" name="TextBox 34"/>
+          <p:cNvSpPr txBox="1"/>
+          <p:nvPr/>
+        </p:nvSpPr>
+        <p:spPr>
+          <a:xfrm>
+            <a:off x="6601968" y="3246120"/>
+            <a:ext cx="4343400" cy="1554480"/>
+          </a:xfrm>
+          <a:prstGeom prst="rect">
+            <a:avLst/>
+          </a:prstGeom>
+          <a:noFill/>
+        </p:spPr>
+        <p:txBody>
+          <a:bodyPr wrap="square">
+            <a:normAutofit/>
+          </a:bodyPr>
+          <a:lstStyle/>
+          <a:p>
+            <a:pPr>
+              <a:spcAft>
+                <a:spcPts val="300"/>
+              </a:spcAft>
+              <a:defRPr sz="950">
+                <a:solidFill>
+                  <a:srgbClr val="222D3D"/>
+                </a:solidFill>
+              </a:defRPr>
+            </a:pPr>
+            <a:r>
+              <a:t>Add real APM traces for end-to-end request paths.</a:t>
+            </a:r>
+          </a:p>
+          <a:p>
+            <a:pPr>
+              <a:spcAft>
+                <a:spcPts val="300"/>
+              </a:spcAft>
+              <a:defRPr sz="950">
+                <a:solidFill>
+                  <a:srgbClr val="222D3D"/>
+                </a:solidFill>
+              </a:defRPr>
+            </a:pPr>
+            <a:r>
+              <a:t>Ingest application logs and infrastructure metrics.</a:t>
+            </a:r>
+          </a:p>
+          <a:p>
+            <a:pPr>
+              <a:spcAft>
+                <a:spcPts val="300"/>
+              </a:spcAft>
+              <a:defRPr sz="950">
+                <a:solidFill>
+                  <a:srgbClr val="222D3D"/>
+                </a:solidFill>
+              </a:defRPr>
+            </a:pPr>
+            <a:r>
+              <a:t>Create alert rules and official Elastic SLO objects.</a:t>
+            </a:r>
+          </a:p>
+        </p:txBody>
+      </p:sp>
+      <p:sp>
+        <p:nvSpPr>
+          <p:cNvPr id="36" name="TextBox 35"/>
+          <p:cNvSpPr txBox="1"/>
+          <p:nvPr/>
+        </p:nvSpPr>
+        <p:spPr>
+          <a:xfrm>
+            <a:off x="868680" y="5897880"/>
+            <a:ext cx="7315200" cy="256032"/>
+          </a:xfrm>
+          <a:prstGeom prst="rect">
+            <a:avLst/>
+          </a:prstGeom>
+          <a:noFill/>
+        </p:spPr>
+        <p:txBody>
+          <a:bodyPr wrap="none">
+            <a:spAutoFit/>
+          </a:bodyPr>
+          <a:lstStyle/>
+          <a:p>
+            <a:r>
+              <a:rPr sz="1000" u="sng">
+                <a:solidFill>
+                  <a:srgbClr val="3673C8"/>
+                </a:solidFill>
+                <a:hlinkClick r:id="rId2"/>
+              </a:rPr>
+              <a:t>Open Payments Observability Dashboard</a:t>
             </a:r>
           </a:p>
         </p:txBody>

</xml_diff>

<commit_message>
Add business scenarios to presentation
Co-authored-by: yanivbtm-git <yanivbtm-git@users.noreply.github.com>
</commit_message>
<xml_diff>
--- a/presentations/payments_dashboards_summary.pptx
+++ b/presentations/payments_dashboards_summary.pptx
@@ -12,11 +12,13 @@
     <p:sldId id="260" r:id="rId11"/>
     <p:sldId id="267" r:id="rId18"/>
     <p:sldId id="261" r:id="rId12"/>
+    <p:sldId id="268" r:id="rId19"/>
     <p:sldId id="262" r:id="rId13"/>
     <p:sldId id="263" r:id="rId14"/>
     <p:sldId id="264" r:id="rId15"/>
     <p:sldId id="265" r:id="rId16"/>
     <p:sldId id="266" r:id="rId17"/>
+    <p:sldId id="269" r:id="rId20"/>
   </p:sldIdLst>
   <p:sldSz cx="12191695" cy="6858000" type="screen4x3"/>
   <p:notesSz cx="6858000" cy="9144000"/>
@@ -3890,7 +3892,7 @@
               </a:defRPr>
             </a:pPr>
             <a:r>
-              <a:t>5</a:t>
+              <a:t>7</a:t>
             </a:r>
           </a:p>
         </p:txBody>
@@ -6422,6 +6424,2756 @@
                 <a:hlinkClick r:id="rId7"/>
               </a:rPr>
               <a:t>Open dashboard</a:t>
+            </a:r>
+          </a:p>
+        </p:txBody>
+      </p:sp>
+    </p:spTree>
+  </p:cSld>
+  <p:clrMapOvr>
+    <a:masterClrMapping/>
+  </p:clrMapOvr>
+</p:sld>
+</file>
+
+<file path=ppt/slides/slide13.xml><?xml version="1.0" encoding="utf-8"?>
+<p:sld xmlns:a="http://schemas.openxmlformats.org/drawingml/2006/main" xmlns:p="http://schemas.openxmlformats.org/presentationml/2006/main" xmlns:r="http://schemas.openxmlformats.org/officeDocument/2006/relationships">
+  <p:cSld>
+    <p:bg>
+      <p:bgPr>
+        <a:solidFill>
+          <a:srgbClr val="F4F8FC"/>
+        </a:solidFill>
+        <a:effectLst/>
+      </p:bgPr>
+    </p:bg>
+    <p:spTree>
+      <p:nvGrpSpPr>
+        <p:cNvPr id="1" name=""/>
+        <p:cNvGrpSpPr/>
+        <p:nvPr/>
+      </p:nvGrpSpPr>
+      <p:grpSpPr/>
+      <p:sp>
+        <p:nvSpPr>
+          <p:cNvPr id="2" name="Rectangle 1"/>
+          <p:cNvSpPr/>
+          <p:nvPr/>
+        </p:nvSpPr>
+        <p:spPr>
+          <a:xfrm>
+            <a:off x="0" y="0"/>
+            <a:ext cx="12191695" cy="164592"/>
+          </a:xfrm>
+          <a:prstGeom prst="rect">
+            <a:avLst/>
+          </a:prstGeom>
+          <a:solidFill>
+            <a:srgbClr val="3673C8"/>
+          </a:solidFill>
+          <a:ln>
+            <a:noFill/>
+          </a:ln>
+        </p:spPr>
+        <p:style>
+          <a:lnRef idx="1">
+            <a:schemeClr val="accent1"/>
+          </a:lnRef>
+          <a:fillRef idx="3">
+            <a:schemeClr val="accent1"/>
+          </a:fillRef>
+          <a:effectRef idx="2">
+            <a:schemeClr val="accent1"/>
+          </a:effectRef>
+          <a:fontRef idx="minor">
+            <a:schemeClr val="lt1"/>
+          </a:fontRef>
+        </p:style>
+        <p:txBody>
+          <a:bodyPr rtlCol="0" anchor="ctr"/>
+          <a:lstStyle/>
+          <a:p>
+            <a:pPr algn="ctr"/>
+          </a:p>
+        </p:txBody>
+      </p:sp>
+      <p:sp>
+        <p:nvSpPr>
+          <p:cNvPr id="3" name="TextBox 2"/>
+          <p:cNvSpPr txBox="1"/>
+          <p:nvPr/>
+        </p:nvSpPr>
+        <p:spPr>
+          <a:xfrm>
+            <a:off x="502920" y="320040"/>
+            <a:ext cx="8961120" cy="502920"/>
+          </a:xfrm>
+          <a:prstGeom prst="rect">
+            <a:avLst/>
+          </a:prstGeom>
+          <a:noFill/>
+        </p:spPr>
+        <p:txBody>
+          <a:bodyPr wrap="none">
+            <a:spAutoFit/>
+          </a:bodyPr>
+          <a:lstStyle/>
+          <a:p>
+            <a:pPr>
+              <a:defRPr sz="2400" b="1">
+                <a:solidFill>
+                  <a:srgbClr val="142440"/>
+                </a:solidFill>
+              </a:defRPr>
+            </a:pPr>
+            <a:r>
+              <a:t>Business Scenarios Dashboard</a:t>
+            </a:r>
+          </a:p>
+        </p:txBody>
+      </p:sp>
+      <p:sp>
+        <p:nvSpPr>
+          <p:cNvPr id="4" name="TextBox 3"/>
+          <p:cNvSpPr txBox="1"/>
+          <p:nvPr/>
+        </p:nvSpPr>
+        <p:spPr>
+          <a:xfrm>
+            <a:off x="530352" y="822960"/>
+            <a:ext cx="9875520" cy="320040"/>
+          </a:xfrm>
+          <a:prstGeom prst="rect">
+            <a:avLst/>
+          </a:prstGeom>
+          <a:noFill/>
+        </p:spPr>
+        <p:txBody>
+          <a:bodyPr wrap="none">
+            <a:spAutoFit/>
+          </a:bodyPr>
+          <a:lstStyle/>
+          <a:p>
+            <a:pPr>
+              <a:defRPr sz="1050">
+                <a:solidFill>
+                  <a:srgbClr val="667487"/>
+                </a:solidFill>
+              </a:defRPr>
+            </a:pPr>
+            <a:r>
+              <a:t>Realistic payment incidents added to make the demo story feel like production data</a:t>
+            </a:r>
+          </a:p>
+        </p:txBody>
+      </p:sp>
+      <p:sp>
+        <p:nvSpPr>
+          <p:cNvPr id="5" name="TextBox 4"/>
+          <p:cNvSpPr txBox="1"/>
+          <p:nvPr/>
+        </p:nvSpPr>
+        <p:spPr>
+          <a:xfrm>
+            <a:off x="502920" y="6446520"/>
+            <a:ext cx="4572000" cy="228600"/>
+          </a:xfrm>
+          <a:prstGeom prst="rect">
+            <a:avLst/>
+          </a:prstGeom>
+          <a:noFill/>
+        </p:spPr>
+        <p:txBody>
+          <a:bodyPr wrap="none">
+            <a:spAutoFit/>
+          </a:bodyPr>
+          <a:lstStyle/>
+          <a:p>
+            <a:pPr>
+              <a:defRPr sz="800">
+                <a:solidFill>
+                  <a:srgbClr val="667487"/>
+                </a:solidFill>
+              </a:defRPr>
+            </a:pPr>
+            <a:r>
+              <a:t>Elastic Payments Analytics Demo</a:t>
+            </a:r>
+          </a:p>
+        </p:txBody>
+      </p:sp>
+      <p:sp>
+        <p:nvSpPr>
+          <p:cNvPr id="6" name="TextBox 5"/>
+          <p:cNvSpPr txBox="1"/>
+          <p:nvPr/>
+        </p:nvSpPr>
+        <p:spPr>
+          <a:xfrm>
+            <a:off x="9326880" y="6446520"/>
+            <a:ext cx="2377440" cy="228600"/>
+          </a:xfrm>
+          <a:prstGeom prst="rect">
+            <a:avLst/>
+          </a:prstGeom>
+          <a:noFill/>
+        </p:spPr>
+        <p:txBody>
+          <a:bodyPr wrap="none">
+            <a:spAutoFit/>
+          </a:bodyPr>
+          <a:lstStyle/>
+          <a:p>
+            <a:pPr algn="r">
+              <a:defRPr sz="800">
+                <a:solidFill>
+                  <a:srgbClr val="667487"/>
+                </a:solidFill>
+              </a:defRPr>
+            </a:pPr>
+            <a:r>
+              <a:t>Jun 10, 2026</a:t>
+            </a:r>
+          </a:p>
+        </p:txBody>
+      </p:sp>
+      <p:sp>
+        <p:nvSpPr>
+          <p:cNvPr id="7" name="Rounded Rectangle 6"/>
+          <p:cNvSpPr/>
+          <p:nvPr/>
+        </p:nvSpPr>
+        <p:spPr>
+          <a:xfrm>
+            <a:off x="502920" y="1234440"/>
+            <a:ext cx="2148840" cy="1005840"/>
+          </a:xfrm>
+          <a:prstGeom prst="roundRect">
+            <a:avLst/>
+          </a:prstGeom>
+          <a:solidFill>
+            <a:srgbClr val="FFFFFF"/>
+          </a:solidFill>
+          <a:ln>
+            <a:solidFill>
+              <a:srgbClr val="D2DDEB"/>
+            </a:solidFill>
+          </a:ln>
+        </p:spPr>
+        <p:style>
+          <a:lnRef idx="1">
+            <a:schemeClr val="accent1"/>
+          </a:lnRef>
+          <a:fillRef idx="3">
+            <a:schemeClr val="accent1"/>
+          </a:fillRef>
+          <a:effectRef idx="2">
+            <a:schemeClr val="accent1"/>
+          </a:effectRef>
+          <a:fontRef idx="minor">
+            <a:schemeClr val="lt1"/>
+          </a:fontRef>
+        </p:style>
+        <p:txBody>
+          <a:bodyPr rtlCol="0" anchor="ctr"/>
+          <a:lstStyle/>
+          <a:p>
+            <a:pPr algn="ctr"/>
+          </a:p>
+        </p:txBody>
+      </p:sp>
+      <p:sp>
+        <p:nvSpPr>
+          <p:cNvPr id="8" name="Rectangle 7"/>
+          <p:cNvSpPr/>
+          <p:nvPr/>
+        </p:nvSpPr>
+        <p:spPr>
+          <a:xfrm>
+            <a:off x="502920" y="1234440"/>
+            <a:ext cx="73152" cy="1005840"/>
+          </a:xfrm>
+          <a:prstGeom prst="rect">
+            <a:avLst/>
+          </a:prstGeom>
+          <a:solidFill>
+            <a:srgbClr val="3673C8"/>
+          </a:solidFill>
+          <a:ln>
+            <a:noFill/>
+          </a:ln>
+        </p:spPr>
+        <p:style>
+          <a:lnRef idx="1">
+            <a:schemeClr val="accent1"/>
+          </a:lnRef>
+          <a:fillRef idx="3">
+            <a:schemeClr val="accent1"/>
+          </a:fillRef>
+          <a:effectRef idx="2">
+            <a:schemeClr val="accent1"/>
+          </a:effectRef>
+          <a:fontRef idx="minor">
+            <a:schemeClr val="lt1"/>
+          </a:fontRef>
+        </p:style>
+        <p:txBody>
+          <a:bodyPr rtlCol="0" anchor="ctr"/>
+          <a:lstStyle/>
+          <a:p>
+            <a:pPr algn="ctr"/>
+          </a:p>
+        </p:txBody>
+      </p:sp>
+      <p:sp>
+        <p:nvSpPr>
+          <p:cNvPr id="9" name="TextBox 8"/>
+          <p:cNvSpPr txBox="1"/>
+          <p:nvPr/>
+        </p:nvSpPr>
+        <p:spPr>
+          <a:xfrm>
+            <a:off x="704088" y="1371600"/>
+            <a:ext cx="1828800" cy="274320"/>
+          </a:xfrm>
+          <a:prstGeom prst="rect">
+            <a:avLst/>
+          </a:prstGeom>
+          <a:noFill/>
+        </p:spPr>
+        <p:txBody>
+          <a:bodyPr wrap="none">
+            <a:spAutoFit/>
+          </a:bodyPr>
+          <a:lstStyle/>
+          <a:p>
+            <a:pPr>
+              <a:defRPr sz="1000" b="1">
+                <a:solidFill>
+                  <a:srgbClr val="667487"/>
+                </a:solidFill>
+              </a:defRPr>
+            </a:pPr>
+            <a:r>
+              <a:t>Scenario Txns</a:t>
+            </a:r>
+          </a:p>
+        </p:txBody>
+      </p:sp>
+      <p:sp>
+        <p:nvSpPr>
+          <p:cNvPr id="10" name="TextBox 9"/>
+          <p:cNvSpPr txBox="1"/>
+          <p:nvPr/>
+        </p:nvSpPr>
+        <p:spPr>
+          <a:xfrm>
+            <a:off x="704088" y="1673352"/>
+            <a:ext cx="1828800" cy="502920"/>
+          </a:xfrm>
+          <a:prstGeom prst="rect">
+            <a:avLst/>
+          </a:prstGeom>
+          <a:noFill/>
+        </p:spPr>
+        <p:txBody>
+          <a:bodyPr wrap="none">
+            <a:spAutoFit/>
+          </a:bodyPr>
+          <a:lstStyle/>
+          <a:p>
+            <a:pPr>
+              <a:defRPr sz="2200" b="1">
+                <a:solidFill>
+                  <a:srgbClr val="142440"/>
+                </a:solidFill>
+              </a:defRPr>
+            </a:pPr>
+            <a:r>
+              <a:t>66,500</a:t>
+            </a:r>
+          </a:p>
+        </p:txBody>
+      </p:sp>
+      <p:sp>
+        <p:nvSpPr>
+          <p:cNvPr id="11" name="Rounded Rectangle 10"/>
+          <p:cNvSpPr/>
+          <p:nvPr/>
+        </p:nvSpPr>
+        <p:spPr>
+          <a:xfrm>
+            <a:off x="2788920" y="1234440"/>
+            <a:ext cx="2148840" cy="1005840"/>
+          </a:xfrm>
+          <a:prstGeom prst="roundRect">
+            <a:avLst/>
+          </a:prstGeom>
+          <a:solidFill>
+            <a:srgbClr val="FFFFFF"/>
+          </a:solidFill>
+          <a:ln>
+            <a:solidFill>
+              <a:srgbClr val="D2DDEB"/>
+            </a:solidFill>
+          </a:ln>
+        </p:spPr>
+        <p:style>
+          <a:lnRef idx="1">
+            <a:schemeClr val="accent1"/>
+          </a:lnRef>
+          <a:fillRef idx="3">
+            <a:schemeClr val="accent1"/>
+          </a:fillRef>
+          <a:effectRef idx="2">
+            <a:schemeClr val="accent1"/>
+          </a:effectRef>
+          <a:fontRef idx="minor">
+            <a:schemeClr val="lt1"/>
+          </a:fontRef>
+        </p:style>
+        <p:txBody>
+          <a:bodyPr rtlCol="0" anchor="ctr"/>
+          <a:lstStyle/>
+          <a:p>
+            <a:pPr algn="ctr"/>
+          </a:p>
+        </p:txBody>
+      </p:sp>
+      <p:sp>
+        <p:nvSpPr>
+          <p:cNvPr id="12" name="Rectangle 11"/>
+          <p:cNvSpPr/>
+          <p:nvPr/>
+        </p:nvSpPr>
+        <p:spPr>
+          <a:xfrm>
+            <a:off x="2788920" y="1234440"/>
+            <a:ext cx="73152" cy="1005840"/>
+          </a:xfrm>
+          <a:prstGeom prst="rect">
+            <a:avLst/>
+          </a:prstGeom>
+          <a:solidFill>
+            <a:srgbClr val="D24848"/>
+          </a:solidFill>
+          <a:ln>
+            <a:noFill/>
+          </a:ln>
+        </p:spPr>
+        <p:style>
+          <a:lnRef idx="1">
+            <a:schemeClr val="accent1"/>
+          </a:lnRef>
+          <a:fillRef idx="3">
+            <a:schemeClr val="accent1"/>
+          </a:fillRef>
+          <a:effectRef idx="2">
+            <a:schemeClr val="accent1"/>
+          </a:effectRef>
+          <a:fontRef idx="minor">
+            <a:schemeClr val="lt1"/>
+          </a:fontRef>
+        </p:style>
+        <p:txBody>
+          <a:bodyPr rtlCol="0" anchor="ctr"/>
+          <a:lstStyle/>
+          <a:p>
+            <a:pPr algn="ctr"/>
+          </a:p>
+        </p:txBody>
+      </p:sp>
+      <p:sp>
+        <p:nvSpPr>
+          <p:cNvPr id="13" name="TextBox 12"/>
+          <p:cNvSpPr txBox="1"/>
+          <p:nvPr/>
+        </p:nvSpPr>
+        <p:spPr>
+          <a:xfrm>
+            <a:off x="2990088" y="1371600"/>
+            <a:ext cx="1828800" cy="274320"/>
+          </a:xfrm>
+          <a:prstGeom prst="rect">
+            <a:avLst/>
+          </a:prstGeom>
+          <a:noFill/>
+        </p:spPr>
+        <p:txBody>
+          <a:bodyPr wrap="none">
+            <a:spAutoFit/>
+          </a:bodyPr>
+          <a:lstStyle/>
+          <a:p>
+            <a:pPr>
+              <a:defRPr sz="1000" b="1">
+                <a:solidFill>
+                  <a:srgbClr val="667487"/>
+                </a:solidFill>
+              </a:defRPr>
+            </a:pPr>
+            <a:r>
+              <a:t>02:00 Failures</a:t>
+            </a:r>
+          </a:p>
+        </p:txBody>
+      </p:sp>
+      <p:sp>
+        <p:nvSpPr>
+          <p:cNvPr id="14" name="TextBox 13"/>
+          <p:cNvSpPr txBox="1"/>
+          <p:nvPr/>
+        </p:nvSpPr>
+        <p:spPr>
+          <a:xfrm>
+            <a:off x="2990088" y="1673352"/>
+            <a:ext cx="1828800" cy="502920"/>
+          </a:xfrm>
+          <a:prstGeom prst="rect">
+            <a:avLst/>
+          </a:prstGeom>
+          <a:noFill/>
+        </p:spPr>
+        <p:txBody>
+          <a:bodyPr wrap="none">
+            <a:spAutoFit/>
+          </a:bodyPr>
+          <a:lstStyle/>
+          <a:p>
+            <a:pPr>
+              <a:defRPr sz="2200" b="1">
+                <a:solidFill>
+                  <a:srgbClr val="142440"/>
+                </a:solidFill>
+              </a:defRPr>
+            </a:pPr>
+            <a:r>
+              <a:t>12,000</a:t>
+            </a:r>
+          </a:p>
+        </p:txBody>
+      </p:sp>
+      <p:sp>
+        <p:nvSpPr>
+          <p:cNvPr id="15" name="Rounded Rectangle 14"/>
+          <p:cNvSpPr/>
+          <p:nvPr/>
+        </p:nvSpPr>
+        <p:spPr>
+          <a:xfrm>
+            <a:off x="5074920" y="1234440"/>
+            <a:ext cx="2148840" cy="1005840"/>
+          </a:xfrm>
+          <a:prstGeom prst="roundRect">
+            <a:avLst/>
+          </a:prstGeom>
+          <a:solidFill>
+            <a:srgbClr val="FFFFFF"/>
+          </a:solidFill>
+          <a:ln>
+            <a:solidFill>
+              <a:srgbClr val="D2DDEB"/>
+            </a:solidFill>
+          </a:ln>
+        </p:spPr>
+        <p:style>
+          <a:lnRef idx="1">
+            <a:schemeClr val="accent1"/>
+          </a:lnRef>
+          <a:fillRef idx="3">
+            <a:schemeClr val="accent1"/>
+          </a:fillRef>
+          <a:effectRef idx="2">
+            <a:schemeClr val="accent1"/>
+          </a:effectRef>
+          <a:fontRef idx="minor">
+            <a:schemeClr val="lt1"/>
+          </a:fontRef>
+        </p:style>
+        <p:txBody>
+          <a:bodyPr rtlCol="0" anchor="ctr"/>
+          <a:lstStyle/>
+          <a:p>
+            <a:pPr algn="ctr"/>
+          </a:p>
+        </p:txBody>
+      </p:sp>
+      <p:sp>
+        <p:nvSpPr>
+          <p:cNvPr id="16" name="Rectangle 15"/>
+          <p:cNvSpPr/>
+          <p:nvPr/>
+        </p:nvSpPr>
+        <p:spPr>
+          <a:xfrm>
+            <a:off x="5074920" y="1234440"/>
+            <a:ext cx="73152" cy="1005840"/>
+          </a:xfrm>
+          <a:prstGeom prst="rect">
+            <a:avLst/>
+          </a:prstGeom>
+          <a:solidFill>
+            <a:srgbClr val="00959C"/>
+          </a:solidFill>
+          <a:ln>
+            <a:noFill/>
+          </a:ln>
+        </p:spPr>
+        <p:style>
+          <a:lnRef idx="1">
+            <a:schemeClr val="accent1"/>
+          </a:lnRef>
+          <a:fillRef idx="3">
+            <a:schemeClr val="accent1"/>
+          </a:fillRef>
+          <a:effectRef idx="2">
+            <a:schemeClr val="accent1"/>
+          </a:effectRef>
+          <a:fontRef idx="minor">
+            <a:schemeClr val="lt1"/>
+          </a:fontRef>
+        </p:style>
+        <p:txBody>
+          <a:bodyPr rtlCol="0" anchor="ctr"/>
+          <a:lstStyle/>
+          <a:p>
+            <a:pPr algn="ctr"/>
+          </a:p>
+        </p:txBody>
+      </p:sp>
+      <p:sp>
+        <p:nvSpPr>
+          <p:cNvPr id="17" name="TextBox 16"/>
+          <p:cNvSpPr txBox="1"/>
+          <p:nvPr/>
+        </p:nvSpPr>
+        <p:spPr>
+          <a:xfrm>
+            <a:off x="5276088" y="1371600"/>
+            <a:ext cx="1828800" cy="274320"/>
+          </a:xfrm>
+          <a:prstGeom prst="rect">
+            <a:avLst/>
+          </a:prstGeom>
+          <a:noFill/>
+        </p:spPr>
+        <p:txBody>
+          <a:bodyPr wrap="none">
+            <a:spAutoFit/>
+          </a:bodyPr>
+          <a:lstStyle/>
+          <a:p>
+            <a:pPr>
+              <a:defRPr sz="1000" b="1">
+                <a:solidFill>
+                  <a:srgbClr val="667487"/>
+                </a:solidFill>
+              </a:defRPr>
+            </a:pPr>
+            <a:r>
+              <a:t>Top Merchant</a:t>
+            </a:r>
+          </a:p>
+        </p:txBody>
+      </p:sp>
+      <p:sp>
+        <p:nvSpPr>
+          <p:cNvPr id="18" name="TextBox 17"/>
+          <p:cNvSpPr txBox="1"/>
+          <p:nvPr/>
+        </p:nvSpPr>
+        <p:spPr>
+          <a:xfrm>
+            <a:off x="5276088" y="1673352"/>
+            <a:ext cx="1828800" cy="502920"/>
+          </a:xfrm>
+          <a:prstGeom prst="rect">
+            <a:avLst/>
+          </a:prstGeom>
+          <a:noFill/>
+        </p:spPr>
+        <p:txBody>
+          <a:bodyPr wrap="none">
+            <a:spAutoFit/>
+          </a:bodyPr>
+          <a:lstStyle/>
+          <a:p>
+            <a:pPr>
+              <a:defRPr sz="2200" b="1">
+                <a:solidFill>
+                  <a:srgbClr val="142440"/>
+                </a:solidFill>
+              </a:defRPr>
+            </a:pPr>
+            <a:r>
+              <a:t>merch-42424</a:t>
+            </a:r>
+          </a:p>
+        </p:txBody>
+      </p:sp>
+      <p:sp>
+        <p:nvSpPr>
+          <p:cNvPr id="19" name="Rounded Rectangle 18"/>
+          <p:cNvSpPr/>
+          <p:nvPr/>
+        </p:nvSpPr>
+        <p:spPr>
+          <a:xfrm>
+            <a:off x="7360920" y="1234440"/>
+            <a:ext cx="2148840" cy="1005840"/>
+          </a:xfrm>
+          <a:prstGeom prst="roundRect">
+            <a:avLst/>
+          </a:prstGeom>
+          <a:solidFill>
+            <a:srgbClr val="FFFFFF"/>
+          </a:solidFill>
+          <a:ln>
+            <a:solidFill>
+              <a:srgbClr val="D2DDEB"/>
+            </a:solidFill>
+          </a:ln>
+        </p:spPr>
+        <p:style>
+          <a:lnRef idx="1">
+            <a:schemeClr val="accent1"/>
+          </a:lnRef>
+          <a:fillRef idx="3">
+            <a:schemeClr val="accent1"/>
+          </a:fillRef>
+          <a:effectRef idx="2">
+            <a:schemeClr val="accent1"/>
+          </a:effectRef>
+          <a:fontRef idx="minor">
+            <a:schemeClr val="lt1"/>
+          </a:fontRef>
+        </p:style>
+        <p:txBody>
+          <a:bodyPr rtlCol="0" anchor="ctr"/>
+          <a:lstStyle/>
+          <a:p>
+            <a:pPr algn="ctr"/>
+          </a:p>
+        </p:txBody>
+      </p:sp>
+      <p:sp>
+        <p:nvSpPr>
+          <p:cNvPr id="20" name="Rectangle 19"/>
+          <p:cNvSpPr/>
+          <p:nvPr/>
+        </p:nvSpPr>
+        <p:spPr>
+          <a:xfrm>
+            <a:off x="7360920" y="1234440"/>
+            <a:ext cx="73152" cy="1005840"/>
+          </a:xfrm>
+          <a:prstGeom prst="rect">
+            <a:avLst/>
+          </a:prstGeom>
+          <a:solidFill>
+            <a:srgbClr val="EF8438"/>
+          </a:solidFill>
+          <a:ln>
+            <a:noFill/>
+          </a:ln>
+        </p:spPr>
+        <p:style>
+          <a:lnRef idx="1">
+            <a:schemeClr val="accent1"/>
+          </a:lnRef>
+          <a:fillRef idx="3">
+            <a:schemeClr val="accent1"/>
+          </a:fillRef>
+          <a:effectRef idx="2">
+            <a:schemeClr val="accent1"/>
+          </a:effectRef>
+          <a:fontRef idx="minor">
+            <a:schemeClr val="lt1"/>
+          </a:fontRef>
+        </p:style>
+        <p:txBody>
+          <a:bodyPr rtlCol="0" anchor="ctr"/>
+          <a:lstStyle/>
+          <a:p>
+            <a:pPr algn="ctr"/>
+          </a:p>
+        </p:txBody>
+      </p:sp>
+      <p:sp>
+        <p:nvSpPr>
+          <p:cNvPr id="21" name="TextBox 20"/>
+          <p:cNvSpPr txBox="1"/>
+          <p:nvPr/>
+        </p:nvSpPr>
+        <p:spPr>
+          <a:xfrm>
+            <a:off x="7562088" y="1371600"/>
+            <a:ext cx="1828800" cy="274320"/>
+          </a:xfrm>
+          <a:prstGeom prst="rect">
+            <a:avLst/>
+          </a:prstGeom>
+          <a:noFill/>
+        </p:spPr>
+        <p:txBody>
+          <a:bodyPr wrap="none">
+            <a:spAutoFit/>
+          </a:bodyPr>
+          <a:lstStyle/>
+          <a:p>
+            <a:pPr>
+              <a:defRPr sz="1000" b="1">
+                <a:solidFill>
+                  <a:srgbClr val="667487"/>
+                </a:solidFill>
+              </a:defRPr>
+            </a:pPr>
+            <a:r>
+              <a:t>Brazil Failure Rate</a:t>
+            </a:r>
+          </a:p>
+        </p:txBody>
+      </p:sp>
+      <p:sp>
+        <p:nvSpPr>
+          <p:cNvPr id="22" name="TextBox 21"/>
+          <p:cNvSpPr txBox="1"/>
+          <p:nvPr/>
+        </p:nvSpPr>
+        <p:spPr>
+          <a:xfrm>
+            <a:off x="7562088" y="1673352"/>
+            <a:ext cx="1828800" cy="502920"/>
+          </a:xfrm>
+          <a:prstGeom prst="rect">
+            <a:avLst/>
+          </a:prstGeom>
+          <a:noFill/>
+        </p:spPr>
+        <p:txBody>
+          <a:bodyPr wrap="none">
+            <a:spAutoFit/>
+          </a:bodyPr>
+          <a:lstStyle/>
+          <a:p>
+            <a:pPr>
+              <a:defRPr sz="2200" b="1">
+                <a:solidFill>
+                  <a:srgbClr val="142440"/>
+                </a:solidFill>
+              </a:defRPr>
+            </a:pPr>
+            <a:r>
+              <a:t>84.29%</a:t>
+            </a:r>
+          </a:p>
+        </p:txBody>
+      </p:sp>
+      <p:sp>
+        <p:nvSpPr>
+          <p:cNvPr id="23" name="Rounded Rectangle 22"/>
+          <p:cNvSpPr/>
+          <p:nvPr/>
+        </p:nvSpPr>
+        <p:spPr>
+          <a:xfrm>
+            <a:off x="9646920" y="1234440"/>
+            <a:ext cx="2057400" cy="1005840"/>
+          </a:xfrm>
+          <a:prstGeom prst="roundRect">
+            <a:avLst/>
+          </a:prstGeom>
+          <a:solidFill>
+            <a:srgbClr val="FFFFFF"/>
+          </a:solidFill>
+          <a:ln>
+            <a:solidFill>
+              <a:srgbClr val="D2DDEB"/>
+            </a:solidFill>
+          </a:ln>
+        </p:spPr>
+        <p:style>
+          <a:lnRef idx="1">
+            <a:schemeClr val="accent1"/>
+          </a:lnRef>
+          <a:fillRef idx="3">
+            <a:schemeClr val="accent1"/>
+          </a:fillRef>
+          <a:effectRef idx="2">
+            <a:schemeClr val="accent1"/>
+          </a:effectRef>
+          <a:fontRef idx="minor">
+            <a:schemeClr val="lt1"/>
+          </a:fontRef>
+        </p:style>
+        <p:txBody>
+          <a:bodyPr rtlCol="0" anchor="ctr"/>
+          <a:lstStyle/>
+          <a:p>
+            <a:pPr algn="ctr"/>
+          </a:p>
+        </p:txBody>
+      </p:sp>
+      <p:sp>
+        <p:nvSpPr>
+          <p:cNvPr id="24" name="Rectangle 23"/>
+          <p:cNvSpPr/>
+          <p:nvPr/>
+        </p:nvSpPr>
+        <p:spPr>
+          <a:xfrm>
+            <a:off x="9646920" y="1234440"/>
+            <a:ext cx="73152" cy="1005840"/>
+          </a:xfrm>
+          <a:prstGeom prst="rect">
+            <a:avLst/>
+          </a:prstGeom>
+          <a:solidFill>
+            <a:srgbClr val="7058BE"/>
+          </a:solidFill>
+          <a:ln>
+            <a:noFill/>
+          </a:ln>
+        </p:spPr>
+        <p:style>
+          <a:lnRef idx="1">
+            <a:schemeClr val="accent1"/>
+          </a:lnRef>
+          <a:fillRef idx="3">
+            <a:schemeClr val="accent1"/>
+          </a:fillRef>
+          <a:effectRef idx="2">
+            <a:schemeClr val="accent1"/>
+          </a:effectRef>
+          <a:fontRef idx="minor">
+            <a:schemeClr val="lt1"/>
+          </a:fontRef>
+        </p:style>
+        <p:txBody>
+          <a:bodyPr rtlCol="0" anchor="ctr"/>
+          <a:lstStyle/>
+          <a:p>
+            <a:pPr algn="ctr"/>
+          </a:p>
+        </p:txBody>
+      </p:sp>
+      <p:sp>
+        <p:nvSpPr>
+          <p:cNvPr id="25" name="TextBox 24"/>
+          <p:cNvSpPr txBox="1"/>
+          <p:nvPr/>
+        </p:nvSpPr>
+        <p:spPr>
+          <a:xfrm>
+            <a:off x="9848088" y="1371600"/>
+            <a:ext cx="1737360" cy="274320"/>
+          </a:xfrm>
+          <a:prstGeom prst="rect">
+            <a:avLst/>
+          </a:prstGeom>
+          <a:noFill/>
+        </p:spPr>
+        <p:txBody>
+          <a:bodyPr wrap="none">
+            <a:spAutoFit/>
+          </a:bodyPr>
+          <a:lstStyle/>
+          <a:p>
+            <a:pPr>
+              <a:defRPr sz="1000" b="1">
+                <a:solidFill>
+                  <a:srgbClr val="667487"/>
+                </a:solidFill>
+              </a:defRPr>
+            </a:pPr>
+            <a:r>
+              <a:t>Latency P95</a:t>
+            </a:r>
+          </a:p>
+        </p:txBody>
+      </p:sp>
+      <p:sp>
+        <p:nvSpPr>
+          <p:cNvPr id="26" name="TextBox 25"/>
+          <p:cNvSpPr txBox="1"/>
+          <p:nvPr/>
+        </p:nvSpPr>
+        <p:spPr>
+          <a:xfrm>
+            <a:off x="9848088" y="1673352"/>
+            <a:ext cx="1737360" cy="502920"/>
+          </a:xfrm>
+          <a:prstGeom prst="rect">
+            <a:avLst/>
+          </a:prstGeom>
+          <a:noFill/>
+        </p:spPr>
+        <p:txBody>
+          <a:bodyPr wrap="none">
+            <a:spAutoFit/>
+          </a:bodyPr>
+          <a:lstStyle/>
+          <a:p>
+            <a:pPr>
+              <a:defRPr sz="2200" b="1">
+                <a:solidFill>
+                  <a:srgbClr val="142440"/>
+                </a:solidFill>
+              </a:defRPr>
+            </a:pPr>
+            <a:r>
+              <a:t>3,279 ms</a:t>
+            </a:r>
+          </a:p>
+        </p:txBody>
+      </p:sp>
+      <p:sp>
+        <p:nvSpPr>
+          <p:cNvPr id="27" name="TextBox 26"/>
+          <p:cNvSpPr txBox="1"/>
+          <p:nvPr/>
+        </p:nvSpPr>
+        <p:spPr>
+          <a:xfrm>
+            <a:off x="822960" y="2788920"/>
+            <a:ext cx="5212080" cy="2057400"/>
+          </a:xfrm>
+          <a:prstGeom prst="rect">
+            <a:avLst/>
+          </a:prstGeom>
+          <a:noFill/>
+        </p:spPr>
+        <p:txBody>
+          <a:bodyPr wrap="square">
+            <a:spAutoFit/>
+          </a:bodyPr>
+          <a:lstStyle/>
+          <a:p>
+            <a:pPr>
+              <a:buChar char="•"/>
+              <a:spcAft>
+                <a:spcPts val="800"/>
+              </a:spcAft>
+              <a:defRPr sz="1400">
+                <a:solidFill>
+                  <a:srgbClr val="222D3D"/>
+                </a:solidFill>
+              </a:defRPr>
+            </a:pPr>
+            <a:r>
+              <a:t>Adds a visible failure spike between 02:00 and 03:00 UTC.</a:t>
+            </a:r>
+          </a:p>
+          <a:p>
+            <a:pPr>
+              <a:buChar char="•"/>
+              <a:spcAft>
+                <a:spcPts val="800"/>
+              </a:spcAft>
+              <a:defRPr sz="1400">
+                <a:solidFill>
+                  <a:srgbClr val="222D3D"/>
+                </a:solidFill>
+              </a:defRPr>
+            </a:pPr>
+            <a:r>
+              <a:t>Merchant merch-42424 becomes an obvious volume outlier with 15,000 transactions.</a:t>
+            </a:r>
+          </a:p>
+          <a:p>
+            <a:pPr>
+              <a:buChar char="•"/>
+              <a:spcAft>
+                <a:spcPts val="800"/>
+              </a:spcAft>
+              <a:defRPr sz="1400">
+                <a:solidFill>
+                  <a:srgbClr val="222D3D"/>
+                </a:solidFill>
+              </a:defRPr>
+            </a:pPr>
+            <a:r>
+              <a:t>Brazil shows an elevated failure rate of 84.29%.</a:t>
+            </a:r>
+          </a:p>
+          <a:p>
+            <a:pPr>
+              <a:buChar char="•"/>
+              <a:spcAft>
+                <a:spcPts val="800"/>
+              </a:spcAft>
+              <a:defRPr sz="1400">
+                <a:solidFill>
+                  <a:srgbClr val="222D3D"/>
+                </a:solidFill>
+              </a:defRPr>
+            </a:pPr>
+            <a:r>
+              <a:t>High-value transactions reach $9,496.</a:t>
+            </a:r>
+          </a:p>
+          <a:p>
+            <a:pPr>
+              <a:buChar char="•"/>
+              <a:spcAft>
+                <a:spcPts val="800"/>
+              </a:spcAft>
+              <a:defRPr sz="1400">
+                <a:solidFill>
+                  <a:srgbClr val="222D3D"/>
+                </a:solidFill>
+              </a:defRPr>
+            </a:pPr>
+            <a:r>
+              <a:t>Latency incident shows baseline around 100ms, jump near 3000ms, and recovery.</a:t>
+            </a:r>
+          </a:p>
+        </p:txBody>
+      </p:sp>
+      <p:sp>
+        <p:nvSpPr>
+          <p:cNvPr id="28" name="TextBox 27"/>
+          <p:cNvSpPr txBox="1"/>
+          <p:nvPr/>
+        </p:nvSpPr>
+        <p:spPr>
+          <a:xfrm>
+            <a:off x="6400800" y="2715768"/>
+            <a:ext cx="4389120" cy="274320"/>
+          </a:xfrm>
+          <a:prstGeom prst="rect">
+            <a:avLst/>
+          </a:prstGeom>
+          <a:noFill/>
+        </p:spPr>
+        <p:txBody>
+          <a:bodyPr wrap="none">
+            <a:spAutoFit/>
+          </a:bodyPr>
+          <a:lstStyle/>
+          <a:p>
+            <a:pPr>
+              <a:defRPr b="1" sz="1200">
+                <a:solidFill>
+                  <a:srgbClr val="142440"/>
+                </a:solidFill>
+              </a:defRPr>
+            </a:pPr>
+            <a:r>
+              <a:t>Scenario volumes</a:t>
+            </a:r>
+          </a:p>
+        </p:txBody>
+      </p:sp>
+      <p:sp>
+        <p:nvSpPr>
+          <p:cNvPr id="29" name="Rectangle 28"/>
+          <p:cNvSpPr/>
+          <p:nvPr/>
+        </p:nvSpPr>
+        <p:spPr>
+          <a:xfrm>
+            <a:off x="6400800" y="3063240"/>
+            <a:ext cx="3291840" cy="347472"/>
+          </a:xfrm>
+          <a:prstGeom prst="rect">
+            <a:avLst/>
+          </a:prstGeom>
+          <a:solidFill>
+            <a:srgbClr val="142440"/>
+          </a:solidFill>
+          <a:ln>
+            <a:solidFill>
+              <a:srgbClr val="FFFFFF"/>
+            </a:solidFill>
+          </a:ln>
+        </p:spPr>
+        <p:style>
+          <a:lnRef idx="1">
+            <a:schemeClr val="accent1"/>
+          </a:lnRef>
+          <a:fillRef idx="3">
+            <a:schemeClr val="accent1"/>
+          </a:fillRef>
+          <a:effectRef idx="2">
+            <a:schemeClr val="accent1"/>
+          </a:effectRef>
+          <a:fontRef idx="minor">
+            <a:schemeClr val="lt1"/>
+          </a:fontRef>
+        </p:style>
+        <p:txBody>
+          <a:bodyPr rtlCol="0" anchor="ctr"/>
+          <a:lstStyle/>
+          <a:p>
+            <a:pPr algn="ctr"/>
+          </a:p>
+        </p:txBody>
+      </p:sp>
+      <p:sp>
+        <p:nvSpPr>
+          <p:cNvPr id="30" name="TextBox 29"/>
+          <p:cNvSpPr txBox="1"/>
+          <p:nvPr/>
+        </p:nvSpPr>
+        <p:spPr>
+          <a:xfrm>
+            <a:off x="6446520" y="3127248"/>
+            <a:ext cx="3200400" cy="292608"/>
+          </a:xfrm>
+          <a:prstGeom prst="rect">
+            <a:avLst/>
+          </a:prstGeom>
+          <a:noFill/>
+        </p:spPr>
+        <p:txBody>
+          <a:bodyPr wrap="none">
+            <a:spAutoFit/>
+          </a:bodyPr>
+          <a:lstStyle/>
+          <a:p>
+            <a:pPr>
+              <a:defRPr sz="850" b="1">
+                <a:solidFill>
+                  <a:srgbClr val="FFFFFF"/>
+                </a:solidFill>
+              </a:defRPr>
+            </a:pPr>
+            <a:r>
+              <a:t>Scenario</a:t>
+            </a:r>
+          </a:p>
+        </p:txBody>
+      </p:sp>
+      <p:sp>
+        <p:nvSpPr>
+          <p:cNvPr id="31" name="Rectangle 30"/>
+          <p:cNvSpPr/>
+          <p:nvPr/>
+        </p:nvSpPr>
+        <p:spPr>
+          <a:xfrm>
+            <a:off x="9692640" y="3063240"/>
+            <a:ext cx="1097280" cy="347472"/>
+          </a:xfrm>
+          <a:prstGeom prst="rect">
+            <a:avLst/>
+          </a:prstGeom>
+          <a:solidFill>
+            <a:srgbClr val="142440"/>
+          </a:solidFill>
+          <a:ln>
+            <a:solidFill>
+              <a:srgbClr val="FFFFFF"/>
+            </a:solidFill>
+          </a:ln>
+        </p:spPr>
+        <p:style>
+          <a:lnRef idx="1">
+            <a:schemeClr val="accent1"/>
+          </a:lnRef>
+          <a:fillRef idx="3">
+            <a:schemeClr val="accent1"/>
+          </a:fillRef>
+          <a:effectRef idx="2">
+            <a:schemeClr val="accent1"/>
+          </a:effectRef>
+          <a:fontRef idx="minor">
+            <a:schemeClr val="lt1"/>
+          </a:fontRef>
+        </p:style>
+        <p:txBody>
+          <a:bodyPr rtlCol="0" anchor="ctr"/>
+          <a:lstStyle/>
+          <a:p>
+            <a:pPr algn="ctr"/>
+          </a:p>
+        </p:txBody>
+      </p:sp>
+      <p:sp>
+        <p:nvSpPr>
+          <p:cNvPr id="32" name="TextBox 31"/>
+          <p:cNvSpPr txBox="1"/>
+          <p:nvPr/>
+        </p:nvSpPr>
+        <p:spPr>
+          <a:xfrm>
+            <a:off x="9738360" y="3127248"/>
+            <a:ext cx="1005839" cy="292608"/>
+          </a:xfrm>
+          <a:prstGeom prst="rect">
+            <a:avLst/>
+          </a:prstGeom>
+          <a:noFill/>
+        </p:spPr>
+        <p:txBody>
+          <a:bodyPr wrap="none">
+            <a:spAutoFit/>
+          </a:bodyPr>
+          <a:lstStyle/>
+          <a:p>
+            <a:pPr>
+              <a:defRPr sz="850" b="1">
+                <a:solidFill>
+                  <a:srgbClr val="FFFFFF"/>
+                </a:solidFill>
+              </a:defRPr>
+            </a:pPr>
+            <a:r>
+              <a:t>Txns</a:t>
+            </a:r>
+          </a:p>
+        </p:txBody>
+      </p:sp>
+      <p:sp>
+        <p:nvSpPr>
+          <p:cNvPr id="33" name="Rectangle 32"/>
+          <p:cNvSpPr/>
+          <p:nvPr/>
+        </p:nvSpPr>
+        <p:spPr>
+          <a:xfrm>
+            <a:off x="6400800" y="3410712"/>
+            <a:ext cx="3291840" cy="347472"/>
+          </a:xfrm>
+          <a:prstGeom prst="rect">
+            <a:avLst/>
+          </a:prstGeom>
+          <a:solidFill>
+            <a:srgbClr val="FFFFFF"/>
+          </a:solidFill>
+          <a:ln>
+            <a:solidFill>
+              <a:srgbClr val="D2DDEB"/>
+            </a:solidFill>
+          </a:ln>
+        </p:spPr>
+        <p:style>
+          <a:lnRef idx="1">
+            <a:schemeClr val="accent1"/>
+          </a:lnRef>
+          <a:fillRef idx="3">
+            <a:schemeClr val="accent1"/>
+          </a:fillRef>
+          <a:effectRef idx="2">
+            <a:schemeClr val="accent1"/>
+          </a:effectRef>
+          <a:fontRef idx="minor">
+            <a:schemeClr val="lt1"/>
+          </a:fontRef>
+        </p:style>
+        <p:txBody>
+          <a:bodyPr rtlCol="0" anchor="ctr"/>
+          <a:lstStyle/>
+          <a:p>
+            <a:pPr algn="ctr"/>
+          </a:p>
+        </p:txBody>
+      </p:sp>
+      <p:sp>
+        <p:nvSpPr>
+          <p:cNvPr id="34" name="TextBox 33"/>
+          <p:cNvSpPr txBox="1"/>
+          <p:nvPr/>
+        </p:nvSpPr>
+        <p:spPr>
+          <a:xfrm>
+            <a:off x="6446520" y="3474720"/>
+            <a:ext cx="3200400" cy="292608"/>
+          </a:xfrm>
+          <a:prstGeom prst="rect">
+            <a:avLst/>
+          </a:prstGeom>
+          <a:noFill/>
+        </p:spPr>
+        <p:txBody>
+          <a:bodyPr wrap="none">
+            <a:spAutoFit/>
+          </a:bodyPr>
+          <a:lstStyle/>
+          <a:p>
+            <a:pPr>
+              <a:defRPr sz="850">
+                <a:solidFill>
+                  <a:srgbClr val="222D3D"/>
+                </a:solidFill>
+              </a:defRPr>
+            </a:pPr>
+            <a:r>
+              <a:t>Brazil elevated decline rate</a:t>
+            </a:r>
+          </a:p>
+        </p:txBody>
+      </p:sp>
+      <p:sp>
+        <p:nvSpPr>
+          <p:cNvPr id="35" name="Rectangle 34"/>
+          <p:cNvSpPr/>
+          <p:nvPr/>
+        </p:nvSpPr>
+        <p:spPr>
+          <a:xfrm>
+            <a:off x="9692640" y="3410712"/>
+            <a:ext cx="1097280" cy="347472"/>
+          </a:xfrm>
+          <a:prstGeom prst="rect">
+            <a:avLst/>
+          </a:prstGeom>
+          <a:solidFill>
+            <a:srgbClr val="FFFFFF"/>
+          </a:solidFill>
+          <a:ln>
+            <a:solidFill>
+              <a:srgbClr val="D2DDEB"/>
+            </a:solidFill>
+          </a:ln>
+        </p:spPr>
+        <p:style>
+          <a:lnRef idx="1">
+            <a:schemeClr val="accent1"/>
+          </a:lnRef>
+          <a:fillRef idx="3">
+            <a:schemeClr val="accent1"/>
+          </a:fillRef>
+          <a:effectRef idx="2">
+            <a:schemeClr val="accent1"/>
+          </a:effectRef>
+          <a:fontRef idx="minor">
+            <a:schemeClr val="lt1"/>
+          </a:fontRef>
+        </p:style>
+        <p:txBody>
+          <a:bodyPr rtlCol="0" anchor="ctr"/>
+          <a:lstStyle/>
+          <a:p>
+            <a:pPr algn="ctr"/>
+          </a:p>
+        </p:txBody>
+      </p:sp>
+      <p:sp>
+        <p:nvSpPr>
+          <p:cNvPr id="36" name="TextBox 35"/>
+          <p:cNvSpPr txBox="1"/>
+          <p:nvPr/>
+        </p:nvSpPr>
+        <p:spPr>
+          <a:xfrm>
+            <a:off x="9738360" y="3474720"/>
+            <a:ext cx="1005839" cy="292608"/>
+          </a:xfrm>
+          <a:prstGeom prst="rect">
+            <a:avLst/>
+          </a:prstGeom>
+          <a:noFill/>
+        </p:spPr>
+        <p:txBody>
+          <a:bodyPr wrap="none">
+            <a:spAutoFit/>
+          </a:bodyPr>
+          <a:lstStyle/>
+          <a:p>
+            <a:pPr>
+              <a:defRPr sz="850">
+                <a:solidFill>
+                  <a:srgbClr val="222D3D"/>
+                </a:solidFill>
+              </a:defRPr>
+            </a:pPr>
+            <a:r>
+              <a:t>22,000</a:t>
+            </a:r>
+          </a:p>
+        </p:txBody>
+      </p:sp>
+      <p:sp>
+        <p:nvSpPr>
+          <p:cNvPr id="37" name="Rectangle 36"/>
+          <p:cNvSpPr/>
+          <p:nvPr/>
+        </p:nvSpPr>
+        <p:spPr>
+          <a:xfrm>
+            <a:off x="6400800" y="3758184"/>
+            <a:ext cx="3291840" cy="347472"/>
+          </a:xfrm>
+          <a:prstGeom prst="rect">
+            <a:avLst/>
+          </a:prstGeom>
+          <a:solidFill>
+            <a:srgbClr val="FFFFFF"/>
+          </a:solidFill>
+          <a:ln>
+            <a:solidFill>
+              <a:srgbClr val="D2DDEB"/>
+            </a:solidFill>
+          </a:ln>
+        </p:spPr>
+        <p:style>
+          <a:lnRef idx="1">
+            <a:schemeClr val="accent1"/>
+          </a:lnRef>
+          <a:fillRef idx="3">
+            <a:schemeClr val="accent1"/>
+          </a:fillRef>
+          <a:effectRef idx="2">
+            <a:schemeClr val="accent1"/>
+          </a:effectRef>
+          <a:fontRef idx="minor">
+            <a:schemeClr val="lt1"/>
+          </a:fontRef>
+        </p:style>
+        <p:txBody>
+          <a:bodyPr rtlCol="0" anchor="ctr"/>
+          <a:lstStyle/>
+          <a:p>
+            <a:pPr algn="ctr"/>
+          </a:p>
+        </p:txBody>
+      </p:sp>
+      <p:sp>
+        <p:nvSpPr>
+          <p:cNvPr id="38" name="TextBox 37"/>
+          <p:cNvSpPr txBox="1"/>
+          <p:nvPr/>
+        </p:nvSpPr>
+        <p:spPr>
+          <a:xfrm>
+            <a:off x="6446520" y="3822192"/>
+            <a:ext cx="3200400" cy="292608"/>
+          </a:xfrm>
+          <a:prstGeom prst="rect">
+            <a:avLst/>
+          </a:prstGeom>
+          <a:noFill/>
+        </p:spPr>
+        <p:txBody>
+          <a:bodyPr wrap="none">
+            <a:spAutoFit/>
+          </a:bodyPr>
+          <a:lstStyle/>
+          <a:p>
+            <a:pPr>
+              <a:defRPr sz="850">
+                <a:solidFill>
+                  <a:srgbClr val="222D3D"/>
+                </a:solidFill>
+              </a:defRPr>
+            </a:pPr>
+            <a:r>
+              <a:t>merchant flash-sale volume spike</a:t>
+            </a:r>
+          </a:p>
+        </p:txBody>
+      </p:sp>
+      <p:sp>
+        <p:nvSpPr>
+          <p:cNvPr id="39" name="Rectangle 38"/>
+          <p:cNvSpPr/>
+          <p:nvPr/>
+        </p:nvSpPr>
+        <p:spPr>
+          <a:xfrm>
+            <a:off x="9692640" y="3758184"/>
+            <a:ext cx="1097280" cy="347472"/>
+          </a:xfrm>
+          <a:prstGeom prst="rect">
+            <a:avLst/>
+          </a:prstGeom>
+          <a:solidFill>
+            <a:srgbClr val="FFFFFF"/>
+          </a:solidFill>
+          <a:ln>
+            <a:solidFill>
+              <a:srgbClr val="D2DDEB"/>
+            </a:solidFill>
+          </a:ln>
+        </p:spPr>
+        <p:style>
+          <a:lnRef idx="1">
+            <a:schemeClr val="accent1"/>
+          </a:lnRef>
+          <a:fillRef idx="3">
+            <a:schemeClr val="accent1"/>
+          </a:fillRef>
+          <a:effectRef idx="2">
+            <a:schemeClr val="accent1"/>
+          </a:effectRef>
+          <a:fontRef idx="minor">
+            <a:schemeClr val="lt1"/>
+          </a:fontRef>
+        </p:style>
+        <p:txBody>
+          <a:bodyPr rtlCol="0" anchor="ctr"/>
+          <a:lstStyle/>
+          <a:p>
+            <a:pPr algn="ctr"/>
+          </a:p>
+        </p:txBody>
+      </p:sp>
+      <p:sp>
+        <p:nvSpPr>
+          <p:cNvPr id="40" name="TextBox 39"/>
+          <p:cNvSpPr txBox="1"/>
+          <p:nvPr/>
+        </p:nvSpPr>
+        <p:spPr>
+          <a:xfrm>
+            <a:off x="9738360" y="3822192"/>
+            <a:ext cx="1005839" cy="292608"/>
+          </a:xfrm>
+          <a:prstGeom prst="rect">
+            <a:avLst/>
+          </a:prstGeom>
+          <a:noFill/>
+        </p:spPr>
+        <p:txBody>
+          <a:bodyPr wrap="none">
+            <a:spAutoFit/>
+          </a:bodyPr>
+          <a:lstStyle/>
+          <a:p>
+            <a:pPr>
+              <a:defRPr sz="850">
+                <a:solidFill>
+                  <a:srgbClr val="222D3D"/>
+                </a:solidFill>
+              </a:defRPr>
+            </a:pPr>
+            <a:r>
+              <a:t>15,000</a:t>
+            </a:r>
+          </a:p>
+        </p:txBody>
+      </p:sp>
+      <p:sp>
+        <p:nvSpPr>
+          <p:cNvPr id="41" name="Rectangle 40"/>
+          <p:cNvSpPr/>
+          <p:nvPr/>
+        </p:nvSpPr>
+        <p:spPr>
+          <a:xfrm>
+            <a:off x="6400800" y="4105656"/>
+            <a:ext cx="3291840" cy="347472"/>
+          </a:xfrm>
+          <a:prstGeom prst="rect">
+            <a:avLst/>
+          </a:prstGeom>
+          <a:solidFill>
+            <a:srgbClr val="FFFFFF"/>
+          </a:solidFill>
+          <a:ln>
+            <a:solidFill>
+              <a:srgbClr val="D2DDEB"/>
+            </a:solidFill>
+          </a:ln>
+        </p:spPr>
+        <p:style>
+          <a:lnRef idx="1">
+            <a:schemeClr val="accent1"/>
+          </a:lnRef>
+          <a:fillRef idx="3">
+            <a:schemeClr val="accent1"/>
+          </a:fillRef>
+          <a:effectRef idx="2">
+            <a:schemeClr val="accent1"/>
+          </a:effectRef>
+          <a:fontRef idx="minor">
+            <a:schemeClr val="lt1"/>
+          </a:fontRef>
+        </p:style>
+        <p:txBody>
+          <a:bodyPr rtlCol="0" anchor="ctr"/>
+          <a:lstStyle/>
+          <a:p>
+            <a:pPr algn="ctr"/>
+          </a:p>
+        </p:txBody>
+      </p:sp>
+      <p:sp>
+        <p:nvSpPr>
+          <p:cNvPr id="42" name="TextBox 41"/>
+          <p:cNvSpPr txBox="1"/>
+          <p:nvPr/>
+        </p:nvSpPr>
+        <p:spPr>
+          <a:xfrm>
+            <a:off x="6446520" y="4169664"/>
+            <a:ext cx="3200400" cy="292608"/>
+          </a:xfrm>
+          <a:prstGeom prst="rect">
+            <a:avLst/>
+          </a:prstGeom>
+          <a:noFill/>
+        </p:spPr>
+        <p:txBody>
+          <a:bodyPr wrap="none">
+            <a:spAutoFit/>
+          </a:bodyPr>
+          <a:lstStyle/>
+          <a:p>
+            <a:pPr>
+              <a:defRPr sz="850">
+                <a:solidFill>
+                  <a:srgbClr val="222D3D"/>
+                </a:solidFill>
+              </a:defRPr>
+            </a:pPr>
+            <a:r>
+              <a:t>02:00-03:00 failure spike</a:t>
+            </a:r>
+          </a:p>
+        </p:txBody>
+      </p:sp>
+      <p:sp>
+        <p:nvSpPr>
+          <p:cNvPr id="43" name="Rectangle 42"/>
+          <p:cNvSpPr/>
+          <p:nvPr/>
+        </p:nvSpPr>
+        <p:spPr>
+          <a:xfrm>
+            <a:off x="9692640" y="4105656"/>
+            <a:ext cx="1097280" cy="347472"/>
+          </a:xfrm>
+          <a:prstGeom prst="rect">
+            <a:avLst/>
+          </a:prstGeom>
+          <a:solidFill>
+            <a:srgbClr val="FFFFFF"/>
+          </a:solidFill>
+          <a:ln>
+            <a:solidFill>
+              <a:srgbClr val="D2DDEB"/>
+            </a:solidFill>
+          </a:ln>
+        </p:spPr>
+        <p:style>
+          <a:lnRef idx="1">
+            <a:schemeClr val="accent1"/>
+          </a:lnRef>
+          <a:fillRef idx="3">
+            <a:schemeClr val="accent1"/>
+          </a:fillRef>
+          <a:effectRef idx="2">
+            <a:schemeClr val="accent1"/>
+          </a:effectRef>
+          <a:fontRef idx="minor">
+            <a:schemeClr val="lt1"/>
+          </a:fontRef>
+        </p:style>
+        <p:txBody>
+          <a:bodyPr rtlCol="0" anchor="ctr"/>
+          <a:lstStyle/>
+          <a:p>
+            <a:pPr algn="ctr"/>
+          </a:p>
+        </p:txBody>
+      </p:sp>
+      <p:sp>
+        <p:nvSpPr>
+          <p:cNvPr id="44" name="TextBox 43"/>
+          <p:cNvSpPr txBox="1"/>
+          <p:nvPr/>
+        </p:nvSpPr>
+        <p:spPr>
+          <a:xfrm>
+            <a:off x="9738360" y="4169664"/>
+            <a:ext cx="1005839" cy="292608"/>
+          </a:xfrm>
+          <a:prstGeom prst="rect">
+            <a:avLst/>
+          </a:prstGeom>
+          <a:noFill/>
+        </p:spPr>
+        <p:txBody>
+          <a:bodyPr wrap="none">
+            <a:spAutoFit/>
+          </a:bodyPr>
+          <a:lstStyle/>
+          <a:p>
+            <a:pPr>
+              <a:defRPr sz="850">
+                <a:solidFill>
+                  <a:srgbClr val="222D3D"/>
+                </a:solidFill>
+              </a:defRPr>
+            </a:pPr>
+            <a:r>
+              <a:t>12,000</a:t>
+            </a:r>
+          </a:p>
+        </p:txBody>
+      </p:sp>
+      <p:sp>
+        <p:nvSpPr>
+          <p:cNvPr id="45" name="Rectangle 44"/>
+          <p:cNvSpPr/>
+          <p:nvPr/>
+        </p:nvSpPr>
+        <p:spPr>
+          <a:xfrm>
+            <a:off x="6400800" y="4453128"/>
+            <a:ext cx="3291840" cy="347472"/>
+          </a:xfrm>
+          <a:prstGeom prst="rect">
+            <a:avLst/>
+          </a:prstGeom>
+          <a:solidFill>
+            <a:srgbClr val="FFFFFF"/>
+          </a:solidFill>
+          <a:ln>
+            <a:solidFill>
+              <a:srgbClr val="D2DDEB"/>
+            </a:solidFill>
+          </a:ln>
+        </p:spPr>
+        <p:style>
+          <a:lnRef idx="1">
+            <a:schemeClr val="accent1"/>
+          </a:lnRef>
+          <a:fillRef idx="3">
+            <a:schemeClr val="accent1"/>
+          </a:fillRef>
+          <a:effectRef idx="2">
+            <a:schemeClr val="accent1"/>
+          </a:effectRef>
+          <a:fontRef idx="minor">
+            <a:schemeClr val="lt1"/>
+          </a:fontRef>
+        </p:style>
+        <p:txBody>
+          <a:bodyPr rtlCol="0" anchor="ctr"/>
+          <a:lstStyle/>
+          <a:p>
+            <a:pPr algn="ctr"/>
+          </a:p>
+        </p:txBody>
+      </p:sp>
+      <p:sp>
+        <p:nvSpPr>
+          <p:cNvPr id="46" name="TextBox 45"/>
+          <p:cNvSpPr txBox="1"/>
+          <p:nvPr/>
+        </p:nvSpPr>
+        <p:spPr>
+          <a:xfrm>
+            <a:off x="6446520" y="4517136"/>
+            <a:ext cx="3200400" cy="292608"/>
+          </a:xfrm>
+          <a:prstGeom prst="rect">
+            <a:avLst/>
+          </a:prstGeom>
+          <a:noFill/>
+        </p:spPr>
+        <p:txBody>
+          <a:bodyPr wrap="none">
+            <a:spAutoFit/>
+          </a:bodyPr>
+          <a:lstStyle/>
+          <a:p>
+            <a:pPr>
+              <a:defRPr sz="850">
+                <a:solidFill>
+                  <a:srgbClr val="222D3D"/>
+                </a:solidFill>
+              </a:defRPr>
+            </a:pPr>
+            <a:r>
+              <a:t>processor latency incident 100ms to 3000ms</a:t>
+            </a:r>
+          </a:p>
+        </p:txBody>
+      </p:sp>
+      <p:sp>
+        <p:nvSpPr>
+          <p:cNvPr id="47" name="Rectangle 46"/>
+          <p:cNvSpPr/>
+          <p:nvPr/>
+        </p:nvSpPr>
+        <p:spPr>
+          <a:xfrm>
+            <a:off x="9692640" y="4453128"/>
+            <a:ext cx="1097280" cy="347472"/>
+          </a:xfrm>
+          <a:prstGeom prst="rect">
+            <a:avLst/>
+          </a:prstGeom>
+          <a:solidFill>
+            <a:srgbClr val="FFFFFF"/>
+          </a:solidFill>
+          <a:ln>
+            <a:solidFill>
+              <a:srgbClr val="D2DDEB"/>
+            </a:solidFill>
+          </a:ln>
+        </p:spPr>
+        <p:style>
+          <a:lnRef idx="1">
+            <a:schemeClr val="accent1"/>
+          </a:lnRef>
+          <a:fillRef idx="3">
+            <a:schemeClr val="accent1"/>
+          </a:fillRef>
+          <a:effectRef idx="2">
+            <a:schemeClr val="accent1"/>
+          </a:effectRef>
+          <a:fontRef idx="minor">
+            <a:schemeClr val="lt1"/>
+          </a:fontRef>
+        </p:style>
+        <p:txBody>
+          <a:bodyPr rtlCol="0" anchor="ctr"/>
+          <a:lstStyle/>
+          <a:p>
+            <a:pPr algn="ctr"/>
+          </a:p>
+        </p:txBody>
+      </p:sp>
+      <p:sp>
+        <p:nvSpPr>
+          <p:cNvPr id="48" name="TextBox 47"/>
+          <p:cNvSpPr txBox="1"/>
+          <p:nvPr/>
+        </p:nvSpPr>
+        <p:spPr>
+          <a:xfrm>
+            <a:off x="9738360" y="4517136"/>
+            <a:ext cx="1005839" cy="292608"/>
+          </a:xfrm>
+          <a:prstGeom prst="rect">
+            <a:avLst/>
+          </a:prstGeom>
+          <a:noFill/>
+        </p:spPr>
+        <p:txBody>
+          <a:bodyPr wrap="none">
+            <a:spAutoFit/>
+          </a:bodyPr>
+          <a:lstStyle/>
+          <a:p>
+            <a:pPr>
+              <a:defRPr sz="850">
+                <a:solidFill>
+                  <a:srgbClr val="222D3D"/>
+                </a:solidFill>
+              </a:defRPr>
+            </a:pPr>
+            <a:r>
+              <a:t>9,000</a:t>
+            </a:r>
+          </a:p>
+        </p:txBody>
+      </p:sp>
+      <p:sp>
+        <p:nvSpPr>
+          <p:cNvPr id="49" name="Rectangle 48"/>
+          <p:cNvSpPr/>
+          <p:nvPr/>
+        </p:nvSpPr>
+        <p:spPr>
+          <a:xfrm>
+            <a:off x="6400800" y="4800600"/>
+            <a:ext cx="3291840" cy="347472"/>
+          </a:xfrm>
+          <a:prstGeom prst="rect">
+            <a:avLst/>
+          </a:prstGeom>
+          <a:solidFill>
+            <a:srgbClr val="FFFFFF"/>
+          </a:solidFill>
+          <a:ln>
+            <a:solidFill>
+              <a:srgbClr val="D2DDEB"/>
+            </a:solidFill>
+          </a:ln>
+        </p:spPr>
+        <p:style>
+          <a:lnRef idx="1">
+            <a:schemeClr val="accent1"/>
+          </a:lnRef>
+          <a:fillRef idx="3">
+            <a:schemeClr val="accent1"/>
+          </a:fillRef>
+          <a:effectRef idx="2">
+            <a:schemeClr val="accent1"/>
+          </a:effectRef>
+          <a:fontRef idx="minor">
+            <a:schemeClr val="lt1"/>
+          </a:fontRef>
+        </p:style>
+        <p:txBody>
+          <a:bodyPr rtlCol="0" anchor="ctr"/>
+          <a:lstStyle/>
+          <a:p>
+            <a:pPr algn="ctr"/>
+          </a:p>
+        </p:txBody>
+      </p:sp>
+      <p:sp>
+        <p:nvSpPr>
+          <p:cNvPr id="50" name="TextBox 49"/>
+          <p:cNvSpPr txBox="1"/>
+          <p:nvPr/>
+        </p:nvSpPr>
+        <p:spPr>
+          <a:xfrm>
+            <a:off x="6446520" y="4864608"/>
+            <a:ext cx="3200400" cy="292608"/>
+          </a:xfrm>
+          <a:prstGeom prst="rect">
+            <a:avLst/>
+          </a:prstGeom>
+          <a:noFill/>
+        </p:spPr>
+        <p:txBody>
+          <a:bodyPr wrap="none">
+            <a:spAutoFit/>
+          </a:bodyPr>
+          <a:lstStyle/>
+          <a:p>
+            <a:pPr>
+              <a:defRPr sz="850">
+                <a:solidFill>
+                  <a:srgbClr val="222D3D"/>
+                </a:solidFill>
+              </a:defRPr>
+            </a:pPr>
+            <a:r>
+              <a:t>high-value transaction cluster</a:t>
+            </a:r>
+          </a:p>
+        </p:txBody>
+      </p:sp>
+      <p:sp>
+        <p:nvSpPr>
+          <p:cNvPr id="51" name="Rectangle 50"/>
+          <p:cNvSpPr/>
+          <p:nvPr/>
+        </p:nvSpPr>
+        <p:spPr>
+          <a:xfrm>
+            <a:off x="9692640" y="4800600"/>
+            <a:ext cx="1097280" cy="347472"/>
+          </a:xfrm>
+          <a:prstGeom prst="rect">
+            <a:avLst/>
+          </a:prstGeom>
+          <a:solidFill>
+            <a:srgbClr val="FFFFFF"/>
+          </a:solidFill>
+          <a:ln>
+            <a:solidFill>
+              <a:srgbClr val="D2DDEB"/>
+            </a:solidFill>
+          </a:ln>
+        </p:spPr>
+        <p:style>
+          <a:lnRef idx="1">
+            <a:schemeClr val="accent1"/>
+          </a:lnRef>
+          <a:fillRef idx="3">
+            <a:schemeClr val="accent1"/>
+          </a:fillRef>
+          <a:effectRef idx="2">
+            <a:schemeClr val="accent1"/>
+          </a:effectRef>
+          <a:fontRef idx="minor">
+            <a:schemeClr val="lt1"/>
+          </a:fontRef>
+        </p:style>
+        <p:txBody>
+          <a:bodyPr rtlCol="0" anchor="ctr"/>
+          <a:lstStyle/>
+          <a:p>
+            <a:pPr algn="ctr"/>
+          </a:p>
+        </p:txBody>
+      </p:sp>
+      <p:sp>
+        <p:nvSpPr>
+          <p:cNvPr id="52" name="TextBox 51"/>
+          <p:cNvSpPr txBox="1"/>
+          <p:nvPr/>
+        </p:nvSpPr>
+        <p:spPr>
+          <a:xfrm>
+            <a:off x="9738360" y="4864608"/>
+            <a:ext cx="1005839" cy="292608"/>
+          </a:xfrm>
+          <a:prstGeom prst="rect">
+            <a:avLst/>
+          </a:prstGeom>
+          <a:noFill/>
+        </p:spPr>
+        <p:txBody>
+          <a:bodyPr wrap="none">
+            <a:spAutoFit/>
+          </a:bodyPr>
+          <a:lstStyle/>
+          <a:p>
+            <a:pPr>
+              <a:defRPr sz="850">
+                <a:solidFill>
+                  <a:srgbClr val="222D3D"/>
+                </a:solidFill>
+              </a:defRPr>
+            </a:pPr>
+            <a:r>
+              <a:t>3,500</a:t>
+            </a:r>
+          </a:p>
+        </p:txBody>
+      </p:sp>
+      <p:sp>
+        <p:nvSpPr>
+          <p:cNvPr id="53" name="Rectangle 52"/>
+          <p:cNvSpPr/>
+          <p:nvPr/>
+        </p:nvSpPr>
+        <p:spPr>
+          <a:xfrm>
+            <a:off x="6400800" y="5148072"/>
+            <a:ext cx="3291840" cy="347472"/>
+          </a:xfrm>
+          <a:prstGeom prst="rect">
+            <a:avLst/>
+          </a:prstGeom>
+          <a:solidFill>
+            <a:srgbClr val="FFFFFF"/>
+          </a:solidFill>
+          <a:ln>
+            <a:solidFill>
+              <a:srgbClr val="D2DDEB"/>
+            </a:solidFill>
+          </a:ln>
+        </p:spPr>
+        <p:style>
+          <a:lnRef idx="1">
+            <a:schemeClr val="accent1"/>
+          </a:lnRef>
+          <a:fillRef idx="3">
+            <a:schemeClr val="accent1"/>
+          </a:fillRef>
+          <a:effectRef idx="2">
+            <a:schemeClr val="accent1"/>
+          </a:effectRef>
+          <a:fontRef idx="minor">
+            <a:schemeClr val="lt1"/>
+          </a:fontRef>
+        </p:style>
+        <p:txBody>
+          <a:bodyPr rtlCol="0" anchor="ctr"/>
+          <a:lstStyle/>
+          <a:p>
+            <a:pPr algn="ctr"/>
+          </a:p>
+        </p:txBody>
+      </p:sp>
+      <p:sp>
+        <p:nvSpPr>
+          <p:cNvPr id="54" name="TextBox 53"/>
+          <p:cNvSpPr txBox="1"/>
+          <p:nvPr/>
+        </p:nvSpPr>
+        <p:spPr>
+          <a:xfrm>
+            <a:off x="6446520" y="5212080"/>
+            <a:ext cx="3200400" cy="292608"/>
+          </a:xfrm>
+          <a:prstGeom prst="rect">
+            <a:avLst/>
+          </a:prstGeom>
+          <a:noFill/>
+        </p:spPr>
+        <p:txBody>
+          <a:bodyPr wrap="none">
+            <a:spAutoFit/>
+          </a:bodyPr>
+          <a:lstStyle/>
+          <a:p>
+            <a:pPr>
+              <a:defRPr sz="850">
+                <a:solidFill>
+                  <a:srgbClr val="222D3D"/>
+                </a:solidFill>
+              </a:defRPr>
+            </a:pPr>
+            <a:r>
+              <a:t>latency recovery after incident</a:t>
+            </a:r>
+          </a:p>
+        </p:txBody>
+      </p:sp>
+      <p:sp>
+        <p:nvSpPr>
+          <p:cNvPr id="55" name="Rectangle 54"/>
+          <p:cNvSpPr/>
+          <p:nvPr/>
+        </p:nvSpPr>
+        <p:spPr>
+          <a:xfrm>
+            <a:off x="9692640" y="5148072"/>
+            <a:ext cx="1097280" cy="347472"/>
+          </a:xfrm>
+          <a:prstGeom prst="rect">
+            <a:avLst/>
+          </a:prstGeom>
+          <a:solidFill>
+            <a:srgbClr val="FFFFFF"/>
+          </a:solidFill>
+          <a:ln>
+            <a:solidFill>
+              <a:srgbClr val="D2DDEB"/>
+            </a:solidFill>
+          </a:ln>
+        </p:spPr>
+        <p:style>
+          <a:lnRef idx="1">
+            <a:schemeClr val="accent1"/>
+          </a:lnRef>
+          <a:fillRef idx="3">
+            <a:schemeClr val="accent1"/>
+          </a:fillRef>
+          <a:effectRef idx="2">
+            <a:schemeClr val="accent1"/>
+          </a:effectRef>
+          <a:fontRef idx="minor">
+            <a:schemeClr val="lt1"/>
+          </a:fontRef>
+        </p:style>
+        <p:txBody>
+          <a:bodyPr rtlCol="0" anchor="ctr"/>
+          <a:lstStyle/>
+          <a:p>
+            <a:pPr algn="ctr"/>
+          </a:p>
+        </p:txBody>
+      </p:sp>
+      <p:sp>
+        <p:nvSpPr>
+          <p:cNvPr id="56" name="TextBox 55"/>
+          <p:cNvSpPr txBox="1"/>
+          <p:nvPr/>
+        </p:nvSpPr>
+        <p:spPr>
+          <a:xfrm>
+            <a:off x="9738360" y="5212080"/>
+            <a:ext cx="1005839" cy="292608"/>
+          </a:xfrm>
+          <a:prstGeom prst="rect">
+            <a:avLst/>
+          </a:prstGeom>
+          <a:noFill/>
+        </p:spPr>
+        <p:txBody>
+          <a:bodyPr wrap="none">
+            <a:spAutoFit/>
+          </a:bodyPr>
+          <a:lstStyle/>
+          <a:p>
+            <a:pPr>
+              <a:defRPr sz="850">
+                <a:solidFill>
+                  <a:srgbClr val="222D3D"/>
+                </a:solidFill>
+              </a:defRPr>
+            </a:pPr>
+            <a:r>
+              <a:t>2,500</a:t>
+            </a:r>
+          </a:p>
+        </p:txBody>
+      </p:sp>
+      <p:sp>
+        <p:nvSpPr>
+          <p:cNvPr id="57" name="TextBox 56"/>
+          <p:cNvSpPr txBox="1"/>
+          <p:nvPr/>
+        </p:nvSpPr>
+        <p:spPr>
+          <a:xfrm>
+            <a:off x="868680" y="5897880"/>
+            <a:ext cx="7315200" cy="256032"/>
+          </a:xfrm>
+          <a:prstGeom prst="rect">
+            <a:avLst/>
+          </a:prstGeom>
+          <a:noFill/>
+        </p:spPr>
+        <p:txBody>
+          <a:bodyPr wrap="none">
+            <a:spAutoFit/>
+          </a:bodyPr>
+          <a:lstStyle/>
+          <a:p>
+            <a:r>
+              <a:rPr sz="1000" u="sng">
+                <a:solidFill>
+                  <a:srgbClr val="3673C8"/>
+                </a:solidFill>
+                <a:hlinkClick r:id="rId2"/>
+              </a:rPr>
+              <a:t>Open Payments Business Scenarios Dashboard</a:t>
+            </a:r>
+          </a:p>
+        </p:txBody>
+      </p:sp>
+    </p:spTree>
+  </p:cSld>
+  <p:clrMapOvr>
+    <a:masterClrMapping/>
+  </p:clrMapOvr>
+</p:sld>
+</file>
+
+<file path=ppt/slides/slide14.xml><?xml version="1.0" encoding="utf-8"?>
+<p:sld xmlns:a="http://schemas.openxmlformats.org/drawingml/2006/main" xmlns:p="http://schemas.openxmlformats.org/presentationml/2006/main" xmlns:r="http://schemas.openxmlformats.org/officeDocument/2006/relationships">
+  <p:cSld>
+    <p:bg>
+      <p:bgPr>
+        <a:solidFill>
+          <a:srgbClr val="F4F8FC"/>
+        </a:solidFill>
+        <a:effectLst/>
+      </p:bgPr>
+    </p:bg>
+    <p:spTree>
+      <p:nvGrpSpPr>
+        <p:cNvPr id="1" name=""/>
+        <p:cNvGrpSpPr/>
+        <p:nvPr/>
+      </p:nvGrpSpPr>
+      <p:grpSpPr/>
+      <p:sp>
+        <p:nvSpPr>
+          <p:cNvPr id="2" name="Rectangle 1"/>
+          <p:cNvSpPr/>
+          <p:nvPr/>
+        </p:nvSpPr>
+        <p:spPr>
+          <a:xfrm>
+            <a:off x="0" y="0"/>
+            <a:ext cx="12191695" cy="164592"/>
+          </a:xfrm>
+          <a:prstGeom prst="rect">
+            <a:avLst/>
+          </a:prstGeom>
+          <a:solidFill>
+            <a:srgbClr val="3673C8"/>
+          </a:solidFill>
+          <a:ln>
+            <a:noFill/>
+          </a:ln>
+        </p:spPr>
+        <p:style>
+          <a:lnRef idx="1">
+            <a:schemeClr val="accent1"/>
+          </a:lnRef>
+          <a:fillRef idx="3">
+            <a:schemeClr val="accent1"/>
+          </a:fillRef>
+          <a:effectRef idx="2">
+            <a:schemeClr val="accent1"/>
+          </a:effectRef>
+          <a:fontRef idx="minor">
+            <a:schemeClr val="lt1"/>
+          </a:fontRef>
+        </p:style>
+        <p:txBody>
+          <a:bodyPr rtlCol="0" anchor="ctr"/>
+          <a:lstStyle/>
+          <a:p>
+            <a:pPr algn="ctr"/>
+          </a:p>
+        </p:txBody>
+      </p:sp>
+      <p:sp>
+        <p:nvSpPr>
+          <p:cNvPr id="3" name="TextBox 2"/>
+          <p:cNvSpPr txBox="1"/>
+          <p:nvPr/>
+        </p:nvSpPr>
+        <p:spPr>
+          <a:xfrm>
+            <a:off x="502920" y="320040"/>
+            <a:ext cx="8961120" cy="502920"/>
+          </a:xfrm>
+          <a:prstGeom prst="rect">
+            <a:avLst/>
+          </a:prstGeom>
+          <a:noFill/>
+        </p:spPr>
+        <p:txBody>
+          <a:bodyPr wrap="none">
+            <a:spAutoFit/>
+          </a:bodyPr>
+          <a:lstStyle/>
+          <a:p>
+            <a:pPr>
+              <a:defRPr sz="2400" b="1">
+                <a:solidFill>
+                  <a:srgbClr val="142440"/>
+                </a:solidFill>
+              </a:defRPr>
+            </a:pPr>
+            <a:r>
+              <a:t>Appendix: business scenario dashboard</a:t>
+            </a:r>
+          </a:p>
+        </p:txBody>
+      </p:sp>
+      <p:sp>
+        <p:nvSpPr>
+          <p:cNvPr id="4" name="TextBox 3"/>
+          <p:cNvSpPr txBox="1"/>
+          <p:nvPr/>
+        </p:nvSpPr>
+        <p:spPr>
+          <a:xfrm>
+            <a:off x="530352" y="822960"/>
+            <a:ext cx="9875520" cy="320040"/>
+          </a:xfrm>
+          <a:prstGeom prst="rect">
+            <a:avLst/>
+          </a:prstGeom>
+          <a:noFill/>
+        </p:spPr>
+        <p:txBody>
+          <a:bodyPr wrap="none">
+            <a:spAutoFit/>
+          </a:bodyPr>
+          <a:lstStyle/>
+          <a:p>
+            <a:pPr>
+              <a:defRPr sz="1050">
+                <a:solidFill>
+                  <a:srgbClr val="667487"/>
+                </a:solidFill>
+              </a:defRPr>
+            </a:pPr>
+            <a:r>
+              <a:t>Additional live link for the realistic incident scenarios</a:t>
+            </a:r>
+          </a:p>
+        </p:txBody>
+      </p:sp>
+      <p:sp>
+        <p:nvSpPr>
+          <p:cNvPr id="5" name="TextBox 4"/>
+          <p:cNvSpPr txBox="1"/>
+          <p:nvPr/>
+        </p:nvSpPr>
+        <p:spPr>
+          <a:xfrm>
+            <a:off x="502920" y="6446520"/>
+            <a:ext cx="4572000" cy="228600"/>
+          </a:xfrm>
+          <a:prstGeom prst="rect">
+            <a:avLst/>
+          </a:prstGeom>
+          <a:noFill/>
+        </p:spPr>
+        <p:txBody>
+          <a:bodyPr wrap="none">
+            <a:spAutoFit/>
+          </a:bodyPr>
+          <a:lstStyle/>
+          <a:p>
+            <a:pPr>
+              <a:defRPr sz="800">
+                <a:solidFill>
+                  <a:srgbClr val="667487"/>
+                </a:solidFill>
+              </a:defRPr>
+            </a:pPr>
+            <a:r>
+              <a:t>Elastic Payments Analytics Demo</a:t>
+            </a:r>
+          </a:p>
+        </p:txBody>
+      </p:sp>
+      <p:sp>
+        <p:nvSpPr>
+          <p:cNvPr id="6" name="TextBox 5"/>
+          <p:cNvSpPr txBox="1"/>
+          <p:nvPr/>
+        </p:nvSpPr>
+        <p:spPr>
+          <a:xfrm>
+            <a:off x="9326880" y="6446520"/>
+            <a:ext cx="2377440" cy="228600"/>
+          </a:xfrm>
+          <a:prstGeom prst="rect">
+            <a:avLst/>
+          </a:prstGeom>
+          <a:noFill/>
+        </p:spPr>
+        <p:txBody>
+          <a:bodyPr wrap="none">
+            <a:spAutoFit/>
+          </a:bodyPr>
+          <a:lstStyle/>
+          <a:p>
+            <a:pPr algn="r">
+              <a:defRPr sz="800">
+                <a:solidFill>
+                  <a:srgbClr val="667487"/>
+                </a:solidFill>
+              </a:defRPr>
+            </a:pPr>
+            <a:r>
+              <a:t>Jun 10, 2026</a:t>
+            </a:r>
+          </a:p>
+        </p:txBody>
+      </p:sp>
+      <p:sp>
+        <p:nvSpPr>
+          <p:cNvPr id="7" name="Rounded Rectangle 6"/>
+          <p:cNvSpPr/>
+          <p:nvPr/>
+        </p:nvSpPr>
+        <p:spPr>
+          <a:xfrm>
+            <a:off x="777240" y="1325880"/>
+            <a:ext cx="10607040" cy="914400"/>
+          </a:xfrm>
+          <a:prstGeom prst="roundRect">
+            <a:avLst/>
+          </a:prstGeom>
+          <a:solidFill>
+            <a:srgbClr val="FFFFFF"/>
+          </a:solidFill>
+          <a:ln>
+            <a:solidFill>
+              <a:srgbClr val="D2DDEB"/>
+            </a:solidFill>
+          </a:ln>
+        </p:spPr>
+        <p:style>
+          <a:lnRef idx="1">
+            <a:schemeClr val="accent1"/>
+          </a:lnRef>
+          <a:fillRef idx="3">
+            <a:schemeClr val="accent1"/>
+          </a:fillRef>
+          <a:effectRef idx="2">
+            <a:schemeClr val="accent1"/>
+          </a:effectRef>
+          <a:fontRef idx="minor">
+            <a:schemeClr val="lt1"/>
+          </a:fontRef>
+        </p:style>
+        <p:txBody>
+          <a:bodyPr rtlCol="0" anchor="ctr"/>
+          <a:lstStyle/>
+          <a:p>
+            <a:pPr algn="ctr"/>
+          </a:p>
+        </p:txBody>
+      </p:sp>
+      <p:sp>
+        <p:nvSpPr>
+          <p:cNvPr id="8" name="Rectangle 7"/>
+          <p:cNvSpPr/>
+          <p:nvPr/>
+        </p:nvSpPr>
+        <p:spPr>
+          <a:xfrm>
+            <a:off x="777240" y="1325880"/>
+            <a:ext cx="73152" cy="914400"/>
+          </a:xfrm>
+          <a:prstGeom prst="rect">
+            <a:avLst/>
+          </a:prstGeom>
+          <a:solidFill>
+            <a:srgbClr val="EF8438"/>
+          </a:solidFill>
+          <a:ln>
+            <a:noFill/>
+          </a:ln>
+        </p:spPr>
+        <p:style>
+          <a:lnRef idx="1">
+            <a:schemeClr val="accent1"/>
+          </a:lnRef>
+          <a:fillRef idx="3">
+            <a:schemeClr val="accent1"/>
+          </a:fillRef>
+          <a:effectRef idx="2">
+            <a:schemeClr val="accent1"/>
+          </a:effectRef>
+          <a:fontRef idx="minor">
+            <a:schemeClr val="lt1"/>
+          </a:fontRef>
+        </p:style>
+        <p:txBody>
+          <a:bodyPr rtlCol="0" anchor="ctr"/>
+          <a:lstStyle/>
+          <a:p>
+            <a:pPr algn="ctr"/>
+          </a:p>
+        </p:txBody>
+      </p:sp>
+      <p:sp>
+        <p:nvSpPr>
+          <p:cNvPr id="9" name="TextBox 8"/>
+          <p:cNvSpPr txBox="1"/>
+          <p:nvPr/>
+        </p:nvSpPr>
+        <p:spPr>
+          <a:xfrm>
+            <a:off x="978408" y="1463039"/>
+            <a:ext cx="10287000" cy="274320"/>
+          </a:xfrm>
+          <a:prstGeom prst="rect">
+            <a:avLst/>
+          </a:prstGeom>
+          <a:noFill/>
+        </p:spPr>
+        <p:txBody>
+          <a:bodyPr wrap="none">
+            <a:spAutoFit/>
+          </a:bodyPr>
+          <a:lstStyle/>
+          <a:p>
+            <a:pPr>
+              <a:defRPr sz="1000" b="1">
+                <a:solidFill>
+                  <a:srgbClr val="667487"/>
+                </a:solidFill>
+              </a:defRPr>
+            </a:pPr>
+            <a:r>
+              <a:t>Payments Business Scenarios Dashboard</a:t>
+            </a:r>
+          </a:p>
+        </p:txBody>
+      </p:sp>
+      <p:sp>
+        <p:nvSpPr>
+          <p:cNvPr id="10" name="TextBox 9"/>
+          <p:cNvSpPr txBox="1"/>
+          <p:nvPr/>
+        </p:nvSpPr>
+        <p:spPr>
+          <a:xfrm>
+            <a:off x="978408" y="1783080"/>
+            <a:ext cx="10287000" cy="228600"/>
+          </a:xfrm>
+          <a:prstGeom prst="rect">
+            <a:avLst/>
+          </a:prstGeom>
+          <a:noFill/>
+        </p:spPr>
+        <p:txBody>
+          <a:bodyPr wrap="square">
+            <a:normAutofit/>
+          </a:bodyPr>
+          <a:lstStyle/>
+          <a:p>
+            <a:pPr>
+              <a:spcAft>
+                <a:spcPts val="300"/>
+              </a:spcAft>
+              <a:defRPr sz="950">
+                <a:solidFill>
+                  <a:srgbClr val="222D3D"/>
+                </a:solidFill>
+              </a:defRPr>
+            </a:pPr>
+            <a:r>
+              <a:t>https://payments-c225aa.kb.us-central1.gcp.elastic.cloud:443/app/dashboards#/view/37d8487c-132f-4c80-9bef-a760f75cf5a0</a:t>
+            </a:r>
+          </a:p>
+        </p:txBody>
+      </p:sp>
+      <p:sp>
+        <p:nvSpPr>
+          <p:cNvPr id="11" name="TextBox 10"/>
+          <p:cNvSpPr txBox="1"/>
+          <p:nvPr/>
+        </p:nvSpPr>
+        <p:spPr>
+          <a:xfrm>
+            <a:off x="1005840" y="1828800"/>
+            <a:ext cx="7315200" cy="256032"/>
+          </a:xfrm>
+          <a:prstGeom prst="rect">
+            <a:avLst/>
+          </a:prstGeom>
+          <a:noFill/>
+        </p:spPr>
+        <p:txBody>
+          <a:bodyPr wrap="none">
+            <a:spAutoFit/>
+          </a:bodyPr>
+          <a:lstStyle/>
+          <a:p>
+            <a:r>
+              <a:rPr sz="1000" u="sng">
+                <a:solidFill>
+                  <a:srgbClr val="3673C8"/>
+                </a:solidFill>
+                <a:hlinkClick r:id="rId2"/>
+              </a:rPr>
+              <a:t>Open dashboard</a:t>
+            </a:r>
+          </a:p>
+        </p:txBody>
+      </p:sp>
+      <p:sp>
+        <p:nvSpPr>
+          <p:cNvPr id="12" name="TextBox 11"/>
+          <p:cNvSpPr txBox="1"/>
+          <p:nvPr/>
+        </p:nvSpPr>
+        <p:spPr>
+          <a:xfrm>
+            <a:off x="914400" y="2834640"/>
+            <a:ext cx="9601200" cy="1828800"/>
+          </a:xfrm>
+          <a:prstGeom prst="rect">
+            <a:avLst/>
+          </a:prstGeom>
+          <a:noFill/>
+        </p:spPr>
+        <p:txBody>
+          <a:bodyPr wrap="square">
+            <a:spAutoFit/>
+          </a:bodyPr>
+          <a:lstStyle/>
+          <a:p>
+            <a:pPr>
+              <a:buChar char="•"/>
+              <a:spcAft>
+                <a:spcPts val="800"/>
+              </a:spcAft>
+              <a:defRPr sz="1500">
+                <a:solidFill>
+                  <a:srgbClr val="222D3D"/>
+                </a:solidFill>
+              </a:defRPr>
+            </a:pPr>
+            <a:r>
+              <a:t>Use this dashboard when presenting the business story: incident spike, merchant outlier, country decline issue, high-value payments and latency outage.</a:t>
+            </a:r>
+          </a:p>
+          <a:p>
+            <a:pPr>
+              <a:buChar char="•"/>
+              <a:spcAft>
+                <a:spcPts val="800"/>
+              </a:spcAft>
+              <a:defRPr sz="1500">
+                <a:solidFill>
+                  <a:srgbClr val="222D3D"/>
+                </a:solidFill>
+              </a:defRPr>
+            </a:pPr>
+            <a:r>
+              <a:t>The dashboard uses a fixed June 10 time range so the scenario remains stable for demos.</a:t>
             </a:r>
           </a:p>
         </p:txBody>

</xml_diff>